<commit_message>
structural and data hazards
</commit_message>
<xml_diff>
--- a/Lec-15-19-pipelined-cpu.pptx
+++ b/Lec-15-19-pipelined-cpu.pptx
@@ -5,7 +5,7 @@
     <p:sldMasterId id="2147483648" r:id="rId1"/>
   </p:sldMasterIdLst>
   <p:notesMasterIdLst>
-    <p:notesMasterId r:id="rId17"/>
+    <p:notesMasterId r:id="rId22"/>
   </p:notesMasterIdLst>
   <p:sldIdLst>
     <p:sldId id="337" r:id="rId2"/>
@@ -20,9 +20,14 @@
     <p:sldId id="346" r:id="rId11"/>
     <p:sldId id="348" r:id="rId12"/>
     <p:sldId id="443" r:id="rId13"/>
-    <p:sldId id="349" r:id="rId14"/>
+    <p:sldId id="444" r:id="rId14"/>
     <p:sldId id="350" r:id="rId15"/>
     <p:sldId id="351" r:id="rId16"/>
+    <p:sldId id="352" r:id="rId17"/>
+    <p:sldId id="353" r:id="rId18"/>
+    <p:sldId id="354" r:id="rId19"/>
+    <p:sldId id="355" r:id="rId20"/>
+    <p:sldId id="356" r:id="rId21"/>
   </p:sldIdLst>
   <p:sldSz cx="9144000" cy="6858000" type="screen4x3"/>
   <p:notesSz cx="6858000" cy="9144000"/>
@@ -304,7 +309,7 @@
               <a:pPr>
                 <a:defRPr/>
               </a:pPr>
-              <a:t>2/20/2026</a:t>
+              <a:t>2/23/2026</a:t>
             </a:fld>
             <a:endParaRPr lang="en-US"/>
           </a:p>
@@ -1285,6 +1290,302 @@
 </file>
 
 <file path=ppt/slideLayouts/slideLayout10.xml><?xml version="1.0" encoding="utf-8"?>
+<p:sldLayout xmlns:a="http://schemas.openxmlformats.org/drawingml/2006/main" xmlns:r="http://schemas.openxmlformats.org/officeDocument/2006/relationships" xmlns:p="http://schemas.openxmlformats.org/presentationml/2006/main" type="picTx" preserve="1">
+  <p:cSld name="Picture with Caption">
+    <p:spTree>
+      <p:nvGrpSpPr>
+        <p:cNvPr id="1" name=""/>
+        <p:cNvGrpSpPr/>
+        <p:nvPr/>
+      </p:nvGrpSpPr>
+      <p:grpSpPr>
+        <a:xfrm>
+          <a:off x="0" y="0"/>
+          <a:ext cx="0" cy="0"/>
+          <a:chOff x="0" y="0"/>
+          <a:chExt cx="0" cy="0"/>
+        </a:xfrm>
+      </p:grpSpPr>
+      <p:sp>
+        <p:nvSpPr>
+          <p:cNvPr id="2" name="Title 1"/>
+          <p:cNvSpPr>
+            <a:spLocks noGrp="1"/>
+          </p:cNvSpPr>
+          <p:nvPr>
+            <p:ph type="title"/>
+          </p:nvPr>
+        </p:nvSpPr>
+        <p:spPr>
+          <a:xfrm>
+            <a:off x="1792288" y="4800600"/>
+            <a:ext cx="5486400" cy="566738"/>
+          </a:xfrm>
+        </p:spPr>
+        <p:txBody>
+          <a:bodyPr anchor="b"/>
+          <a:lstStyle>
+            <a:lvl1pPr algn="l">
+              <a:defRPr sz="2000" b="1"/>
+            </a:lvl1pPr>
+          </a:lstStyle>
+          <a:p>
+            <a:r>
+              <a:rPr lang="en-US"/>
+              <a:t>Click to edit Master title style</a:t>
+            </a:r>
+          </a:p>
+        </p:txBody>
+      </p:sp>
+      <p:sp>
+        <p:nvSpPr>
+          <p:cNvPr id="3" name="Picture Placeholder 2"/>
+          <p:cNvSpPr>
+            <a:spLocks noGrp="1"/>
+          </p:cNvSpPr>
+          <p:nvPr>
+            <p:ph type="pic" idx="1"/>
+          </p:nvPr>
+        </p:nvSpPr>
+        <p:spPr>
+          <a:xfrm>
+            <a:off x="1792288" y="612775"/>
+            <a:ext cx="5486400" cy="4114800"/>
+          </a:xfrm>
+        </p:spPr>
+        <p:txBody>
+          <a:bodyPr rtlCol="0">
+            <a:normAutofit/>
+          </a:bodyPr>
+          <a:lstStyle>
+            <a:lvl1pPr marL="0" indent="0">
+              <a:buNone/>
+              <a:defRPr sz="3200"/>
+            </a:lvl1pPr>
+            <a:lvl2pPr marL="457200" indent="0">
+              <a:buNone/>
+              <a:defRPr sz="2800"/>
+            </a:lvl2pPr>
+            <a:lvl3pPr marL="914400" indent="0">
+              <a:buNone/>
+              <a:defRPr sz="2400"/>
+            </a:lvl3pPr>
+            <a:lvl4pPr marL="1371600" indent="0">
+              <a:buNone/>
+              <a:defRPr sz="2000"/>
+            </a:lvl4pPr>
+            <a:lvl5pPr marL="1828800" indent="0">
+              <a:buNone/>
+              <a:defRPr sz="2000"/>
+            </a:lvl5pPr>
+            <a:lvl6pPr marL="2286000" indent="0">
+              <a:buNone/>
+              <a:defRPr sz="2000"/>
+            </a:lvl6pPr>
+            <a:lvl7pPr marL="2743200" indent="0">
+              <a:buNone/>
+              <a:defRPr sz="2000"/>
+            </a:lvl7pPr>
+            <a:lvl8pPr marL="3200400" indent="0">
+              <a:buNone/>
+              <a:defRPr sz="2000"/>
+            </a:lvl8pPr>
+            <a:lvl9pPr marL="3657600" indent="0">
+              <a:buNone/>
+              <a:defRPr sz="2000"/>
+            </a:lvl9pPr>
+          </a:lstStyle>
+          <a:p>
+            <a:pPr lvl="0"/>
+            <a:endParaRPr lang="en-US" noProof="0"/>
+          </a:p>
+        </p:txBody>
+      </p:sp>
+      <p:sp>
+        <p:nvSpPr>
+          <p:cNvPr id="4" name="Text Placeholder 3"/>
+          <p:cNvSpPr>
+            <a:spLocks noGrp="1"/>
+          </p:cNvSpPr>
+          <p:nvPr>
+            <p:ph type="body" sz="half" idx="2"/>
+          </p:nvPr>
+        </p:nvSpPr>
+        <p:spPr>
+          <a:xfrm>
+            <a:off x="1792288" y="5367338"/>
+            <a:ext cx="5486400" cy="804862"/>
+          </a:xfrm>
+        </p:spPr>
+        <p:txBody>
+          <a:bodyPr/>
+          <a:lstStyle>
+            <a:lvl1pPr marL="0" indent="0">
+              <a:buNone/>
+              <a:defRPr sz="1400"/>
+            </a:lvl1pPr>
+            <a:lvl2pPr marL="457200" indent="0">
+              <a:buNone/>
+              <a:defRPr sz="1200"/>
+            </a:lvl2pPr>
+            <a:lvl3pPr marL="914400" indent="0">
+              <a:buNone/>
+              <a:defRPr sz="1000"/>
+            </a:lvl3pPr>
+            <a:lvl4pPr marL="1371600" indent="0">
+              <a:buNone/>
+              <a:defRPr sz="900"/>
+            </a:lvl4pPr>
+            <a:lvl5pPr marL="1828800" indent="0">
+              <a:buNone/>
+              <a:defRPr sz="900"/>
+            </a:lvl5pPr>
+            <a:lvl6pPr marL="2286000" indent="0">
+              <a:buNone/>
+              <a:defRPr sz="900"/>
+            </a:lvl6pPr>
+            <a:lvl7pPr marL="2743200" indent="0">
+              <a:buNone/>
+              <a:defRPr sz="900"/>
+            </a:lvl7pPr>
+            <a:lvl8pPr marL="3200400" indent="0">
+              <a:buNone/>
+              <a:defRPr sz="900"/>
+            </a:lvl8pPr>
+            <a:lvl9pPr marL="3657600" indent="0">
+              <a:buNone/>
+              <a:defRPr sz="900"/>
+            </a:lvl9pPr>
+          </a:lstStyle>
+          <a:p>
+            <a:pPr lvl="0"/>
+            <a:r>
+              <a:rPr lang="en-US"/>
+              <a:t>Click to edit Master text styles</a:t>
+            </a:r>
+          </a:p>
+        </p:txBody>
+      </p:sp>
+      <p:sp>
+        <p:nvSpPr>
+          <p:cNvPr id="5" name="Date Placeholder 3">
+            <a:extLst>
+              <a:ext uri="{FF2B5EF4-FFF2-40B4-BE49-F238E27FC236}">
+                <a16:creationId xmlns:a16="http://schemas.microsoft.com/office/drawing/2014/main" id="{AE467ABF-5DBD-0F44-6269-D1296B669355}"/>
+              </a:ext>
+            </a:extLst>
+          </p:cNvPr>
+          <p:cNvSpPr>
+            <a:spLocks noGrp="1"/>
+          </p:cNvSpPr>
+          <p:nvPr>
+            <p:ph type="dt" sz="half" idx="10"/>
+          </p:nvPr>
+        </p:nvSpPr>
+        <p:spPr/>
+        <p:txBody>
+          <a:bodyPr/>
+          <a:lstStyle>
+            <a:lvl1pPr>
+              <a:defRPr/>
+            </a:lvl1pPr>
+          </a:lstStyle>
+          <a:p>
+            <a:pPr>
+              <a:defRPr/>
+            </a:pPr>
+            <a:r>
+              <a:rPr lang="en-US"/>
+              <a:t>21/12/2020</a:t>
+            </a:r>
+          </a:p>
+        </p:txBody>
+      </p:sp>
+      <p:sp>
+        <p:nvSpPr>
+          <p:cNvPr id="6" name="Footer Placeholder 4">
+            <a:extLst>
+              <a:ext uri="{FF2B5EF4-FFF2-40B4-BE49-F238E27FC236}">
+                <a16:creationId xmlns:a16="http://schemas.microsoft.com/office/drawing/2014/main" id="{31729259-95EB-ABB4-8CC1-6AAA526DCDAA}"/>
+              </a:ext>
+            </a:extLst>
+          </p:cNvPr>
+          <p:cNvSpPr>
+            <a:spLocks noGrp="1"/>
+          </p:cNvSpPr>
+          <p:nvPr>
+            <p:ph type="ftr" sz="quarter" idx="11"/>
+          </p:nvPr>
+        </p:nvSpPr>
+        <p:spPr/>
+        <p:txBody>
+          <a:bodyPr/>
+          <a:lstStyle>
+            <a:lvl1pPr>
+              <a:defRPr/>
+            </a:lvl1pPr>
+          </a:lstStyle>
+          <a:p>
+            <a:pPr>
+              <a:defRPr/>
+            </a:pPr>
+            <a:endParaRPr lang="en-US"/>
+          </a:p>
+        </p:txBody>
+      </p:sp>
+      <p:sp>
+        <p:nvSpPr>
+          <p:cNvPr id="7" name="Slide Number Placeholder 5">
+            <a:extLst>
+              <a:ext uri="{FF2B5EF4-FFF2-40B4-BE49-F238E27FC236}">
+                <a16:creationId xmlns:a16="http://schemas.microsoft.com/office/drawing/2014/main" id="{762D7086-DF65-36F8-E6B6-082068B3EE8C}"/>
+              </a:ext>
+            </a:extLst>
+          </p:cNvPr>
+          <p:cNvSpPr>
+            <a:spLocks noGrp="1"/>
+          </p:cNvSpPr>
+          <p:nvPr>
+            <p:ph type="sldNum" sz="quarter" idx="12"/>
+          </p:nvPr>
+        </p:nvSpPr>
+        <p:spPr/>
+        <p:txBody>
+          <a:bodyPr/>
+          <a:lstStyle>
+            <a:lvl1pPr>
+              <a:defRPr/>
+            </a:lvl1pPr>
+          </a:lstStyle>
+          <a:p>
+            <a:pPr>
+              <a:defRPr/>
+            </a:pPr>
+            <a:fld id="{FB2052F0-E69A-488D-AA78-DE7ABB9591C3}" type="slidenum">
+              <a:rPr lang="en-US" altLang="en-US"/>
+              <a:pPr>
+                <a:defRPr/>
+              </a:pPr>
+              <a:t>‹#›</a:t>
+            </a:fld>
+            <a:endParaRPr lang="en-US" altLang="en-US"/>
+          </a:p>
+        </p:txBody>
+      </p:sp>
+    </p:spTree>
+    <p:extLst>
+      <p:ext uri="{BB962C8B-B14F-4D97-AF65-F5344CB8AC3E}">
+        <p14:creationId xmlns:p14="http://schemas.microsoft.com/office/powerpoint/2010/main" val="2265026697"/>
+      </p:ext>
+    </p:extLst>
+  </p:cSld>
+  <p:clrMapOvr>
+    <a:masterClrMapping/>
+  </p:clrMapOvr>
+</p:sldLayout>
+</file>
+
+<file path=ppt/slideLayouts/slideLayout11.xml><?xml version="1.0" encoding="utf-8"?>
 <p:sldLayout xmlns:a="http://schemas.openxmlformats.org/drawingml/2006/main" xmlns:r="http://schemas.openxmlformats.org/officeDocument/2006/relationships" xmlns:p="http://schemas.openxmlformats.org/presentationml/2006/main" type="vertTx" preserve="1">
   <p:cSld name="Title and Vertical Text">
     <p:spTree>
@@ -1493,7 +1794,7 @@
 </p:sldLayout>
 </file>
 
-<file path=ppt/slideLayouts/slideLayout11.xml><?xml version="1.0" encoding="utf-8"?>
+<file path=ppt/slideLayouts/slideLayout12.xml><?xml version="1.0" encoding="utf-8"?>
 <p:sldLayout xmlns:a="http://schemas.openxmlformats.org/drawingml/2006/main" xmlns:r="http://schemas.openxmlformats.org/officeDocument/2006/relationships" xmlns:p="http://schemas.openxmlformats.org/presentationml/2006/main" type="vertTitleAndTx" preserve="1">
   <p:cSld name="Vertical Title and Text">
     <p:spTree>
@@ -1712,8 +2013,8 @@
 </p:sldLayout>
 </file>
 
-<file path=ppt/slideLayouts/slideLayout12.xml><?xml version="1.0" encoding="utf-8"?>
-<p:sldLayout xmlns:a="http://schemas.openxmlformats.org/drawingml/2006/main" xmlns:r="http://schemas.openxmlformats.org/officeDocument/2006/relationships" xmlns:p="http://schemas.openxmlformats.org/presentationml/2006/main" userDrawn="1">
+<file path=ppt/slideLayouts/slideLayout2.xml><?xml version="1.0" encoding="utf-8"?>
+<p:sldLayout xmlns:a="http://schemas.openxmlformats.org/drawingml/2006/main" xmlns:r="http://schemas.openxmlformats.org/officeDocument/2006/relationships" xmlns:p="http://schemas.openxmlformats.org/presentationml/2006/main" showMasterSp="0" userDrawn="1">
   <p:cSld name="Custom Layout">
     <p:bg>
       <p:bgPr>
@@ -2308,6 +2609,66 @@
           </a:p>
         </p:txBody>
       </p:sp>
+      <p:pic>
+        <p:nvPicPr>
+          <p:cNvPr id="11" name="Picture 11" descr="Picture 7.png">
+            <a:extLst>
+              <a:ext uri="{FF2B5EF4-FFF2-40B4-BE49-F238E27FC236}">
+                <a16:creationId xmlns:a16="http://schemas.microsoft.com/office/drawing/2014/main" id="{69F4A35B-A00F-8EED-48E9-204F14156994}"/>
+              </a:ext>
+            </a:extLst>
+          </p:cNvPr>
+          <p:cNvPicPr>
+            <a:picLocks noChangeAspect="1"/>
+          </p:cNvPicPr>
+          <p:nvPr userDrawn="1"/>
+        </p:nvPicPr>
+        <p:blipFill>
+          <a:blip r:embed="rId4">
+            <a:extLst>
+              <a:ext uri="{28A0092B-C50C-407E-A947-70E740481C1C}">
+                <a14:useLocalDpi xmlns:a14="http://schemas.microsoft.com/office/drawing/2010/main" val="0"/>
+              </a:ext>
+            </a:extLst>
+          </a:blip>
+          <a:srcRect l="1923" b="5336"/>
+          <a:stretch>
+            <a:fillRect/>
+          </a:stretch>
+        </p:blipFill>
+        <p:spPr bwMode="auto">
+          <a:xfrm>
+            <a:off x="6629400" y="0"/>
+            <a:ext cx="2193925" cy="692150"/>
+          </a:xfrm>
+          <a:prstGeom prst="rect">
+            <a:avLst/>
+          </a:prstGeom>
+          <a:noFill/>
+          <a:ln>
+            <a:noFill/>
+          </a:ln>
+          <a:extLst>
+            <a:ext uri="{909E8E84-426E-40DD-AFC4-6F175D3DCCD1}">
+              <a14:hiddenFill xmlns:a14="http://schemas.microsoft.com/office/drawing/2010/main">
+                <a:solidFill>
+                  <a:srgbClr val="FFFFFF"/>
+                </a:solidFill>
+              </a14:hiddenFill>
+            </a:ext>
+            <a:ext uri="{91240B29-F687-4F45-9708-019B960494DF}">
+              <a14:hiddenLine xmlns:a14="http://schemas.microsoft.com/office/drawing/2010/main" w="9525">
+                <a:solidFill>
+                  <a:srgbClr val="000000"/>
+                </a:solidFill>
+                <a:miter lim="800000"/>
+                <a:headEnd/>
+                <a:tailEnd/>
+              </a14:hiddenLine>
+            </a:ext>
+          </a:extLst>
+        </p:spPr>
+      </p:pic>
     </p:spTree>
     <p:extLst>
       <p:ext uri="{BB962C8B-B14F-4D97-AF65-F5344CB8AC3E}">
@@ -2321,7 +2682,7 @@
 </p:sldLayout>
 </file>
 
-<file path=ppt/slideLayouts/slideLayout2.xml><?xml version="1.0" encoding="utf-8"?>
+<file path=ppt/slideLayouts/slideLayout3.xml><?xml version="1.0" encoding="utf-8"?>
 <p:sldLayout xmlns:a="http://schemas.openxmlformats.org/drawingml/2006/main" xmlns:r="http://schemas.openxmlformats.org/officeDocument/2006/relationships" xmlns:p="http://schemas.openxmlformats.org/presentationml/2006/main" type="obj" preserve="1">
   <p:cSld name="Title and Content">
     <p:spTree>
@@ -2589,7 +2950,7 @@
 </p:sldLayout>
 </file>
 
-<file path=ppt/slideLayouts/slideLayout3.xml><?xml version="1.0" encoding="utf-8"?>
+<file path=ppt/slideLayouts/slideLayout4.xml><?xml version="1.0" encoding="utf-8"?>
 <p:sldLayout xmlns:a="http://schemas.openxmlformats.org/drawingml/2006/main" xmlns:r="http://schemas.openxmlformats.org/officeDocument/2006/relationships" xmlns:p="http://schemas.openxmlformats.org/presentationml/2006/main" preserve="1" userDrawn="1">
   <p:cSld name="Section Header">
     <p:spTree>
@@ -2876,7 +3237,7 @@
 </p:sldLayout>
 </file>
 
-<file path=ppt/slideLayouts/slideLayout4.xml><?xml version="1.0" encoding="utf-8"?>
+<file path=ppt/slideLayouts/slideLayout5.xml><?xml version="1.0" encoding="utf-8"?>
 <p:sldLayout xmlns:a="http://schemas.openxmlformats.org/drawingml/2006/main" xmlns:r="http://schemas.openxmlformats.org/officeDocument/2006/relationships" xmlns:p="http://schemas.openxmlformats.org/presentationml/2006/main" type="twoObj" preserve="1">
   <p:cSld name="Two Content">
     <p:spTree>
@@ -3202,7 +3563,7 @@
 </p:sldLayout>
 </file>
 
-<file path=ppt/slideLayouts/slideLayout5.xml><?xml version="1.0" encoding="utf-8"?>
+<file path=ppt/slideLayouts/slideLayout6.xml><?xml version="1.0" encoding="utf-8"?>
 <p:sldLayout xmlns:a="http://schemas.openxmlformats.org/drawingml/2006/main" xmlns:r="http://schemas.openxmlformats.org/officeDocument/2006/relationships" xmlns:p="http://schemas.openxmlformats.org/presentationml/2006/main" type="twoTxTwoObj" preserve="1">
   <p:cSld name="Comparison">
     <p:spTree>
@@ -3662,7 +4023,7 @@
 </p:sldLayout>
 </file>
 
-<file path=ppt/slideLayouts/slideLayout6.xml><?xml version="1.0" encoding="utf-8"?>
+<file path=ppt/slideLayouts/slideLayout7.xml><?xml version="1.0" encoding="utf-8"?>
 <p:sldLayout xmlns:a="http://schemas.openxmlformats.org/drawingml/2006/main" xmlns:r="http://schemas.openxmlformats.org/officeDocument/2006/relationships" xmlns:p="http://schemas.openxmlformats.org/presentationml/2006/main" type="titleOnly" preserve="1">
   <p:cSld name="Title Only">
     <p:spTree>
@@ -3820,7 +4181,7 @@
 </p:sldLayout>
 </file>
 
-<file path=ppt/slideLayouts/slideLayout7.xml><?xml version="1.0" encoding="utf-8"?>
+<file path=ppt/slideLayouts/slideLayout8.xml><?xml version="1.0" encoding="utf-8"?>
 <p:sldLayout xmlns:a="http://schemas.openxmlformats.org/drawingml/2006/main" xmlns:r="http://schemas.openxmlformats.org/officeDocument/2006/relationships" xmlns:p="http://schemas.openxmlformats.org/presentationml/2006/main" type="blank" preserve="1">
   <p:cSld name="Blank">
     <p:spTree>
@@ -3956,7 +4317,7 @@
 </p:sldLayout>
 </file>
 
-<file path=ppt/slideLayouts/slideLayout8.xml><?xml version="1.0" encoding="utf-8"?>
+<file path=ppt/slideLayouts/slideLayout9.xml><?xml version="1.0" encoding="utf-8"?>
 <p:sldLayout xmlns:a="http://schemas.openxmlformats.org/drawingml/2006/main" xmlns:r="http://schemas.openxmlformats.org/officeDocument/2006/relationships" xmlns:p="http://schemas.openxmlformats.org/presentationml/2006/main" type="objTx" preserve="1">
   <p:cSld name="Content with Caption">
     <p:spTree>
@@ -4263,302 +4624,6 @@
     <p:extLst>
       <p:ext uri="{BB962C8B-B14F-4D97-AF65-F5344CB8AC3E}">
         <p14:creationId xmlns:p14="http://schemas.microsoft.com/office/powerpoint/2010/main" val="3820446429"/>
-      </p:ext>
-    </p:extLst>
-  </p:cSld>
-  <p:clrMapOvr>
-    <a:masterClrMapping/>
-  </p:clrMapOvr>
-</p:sldLayout>
-</file>
-
-<file path=ppt/slideLayouts/slideLayout9.xml><?xml version="1.0" encoding="utf-8"?>
-<p:sldLayout xmlns:a="http://schemas.openxmlformats.org/drawingml/2006/main" xmlns:r="http://schemas.openxmlformats.org/officeDocument/2006/relationships" xmlns:p="http://schemas.openxmlformats.org/presentationml/2006/main" type="picTx" preserve="1">
-  <p:cSld name="Picture with Caption">
-    <p:spTree>
-      <p:nvGrpSpPr>
-        <p:cNvPr id="1" name=""/>
-        <p:cNvGrpSpPr/>
-        <p:nvPr/>
-      </p:nvGrpSpPr>
-      <p:grpSpPr>
-        <a:xfrm>
-          <a:off x="0" y="0"/>
-          <a:ext cx="0" cy="0"/>
-          <a:chOff x="0" y="0"/>
-          <a:chExt cx="0" cy="0"/>
-        </a:xfrm>
-      </p:grpSpPr>
-      <p:sp>
-        <p:nvSpPr>
-          <p:cNvPr id="2" name="Title 1"/>
-          <p:cNvSpPr>
-            <a:spLocks noGrp="1"/>
-          </p:cNvSpPr>
-          <p:nvPr>
-            <p:ph type="title"/>
-          </p:nvPr>
-        </p:nvSpPr>
-        <p:spPr>
-          <a:xfrm>
-            <a:off x="1792288" y="4800600"/>
-            <a:ext cx="5486400" cy="566738"/>
-          </a:xfrm>
-        </p:spPr>
-        <p:txBody>
-          <a:bodyPr anchor="b"/>
-          <a:lstStyle>
-            <a:lvl1pPr algn="l">
-              <a:defRPr sz="2000" b="1"/>
-            </a:lvl1pPr>
-          </a:lstStyle>
-          <a:p>
-            <a:r>
-              <a:rPr lang="en-US"/>
-              <a:t>Click to edit Master title style</a:t>
-            </a:r>
-          </a:p>
-        </p:txBody>
-      </p:sp>
-      <p:sp>
-        <p:nvSpPr>
-          <p:cNvPr id="3" name="Picture Placeholder 2"/>
-          <p:cNvSpPr>
-            <a:spLocks noGrp="1"/>
-          </p:cNvSpPr>
-          <p:nvPr>
-            <p:ph type="pic" idx="1"/>
-          </p:nvPr>
-        </p:nvSpPr>
-        <p:spPr>
-          <a:xfrm>
-            <a:off x="1792288" y="612775"/>
-            <a:ext cx="5486400" cy="4114800"/>
-          </a:xfrm>
-        </p:spPr>
-        <p:txBody>
-          <a:bodyPr rtlCol="0">
-            <a:normAutofit/>
-          </a:bodyPr>
-          <a:lstStyle>
-            <a:lvl1pPr marL="0" indent="0">
-              <a:buNone/>
-              <a:defRPr sz="3200"/>
-            </a:lvl1pPr>
-            <a:lvl2pPr marL="457200" indent="0">
-              <a:buNone/>
-              <a:defRPr sz="2800"/>
-            </a:lvl2pPr>
-            <a:lvl3pPr marL="914400" indent="0">
-              <a:buNone/>
-              <a:defRPr sz="2400"/>
-            </a:lvl3pPr>
-            <a:lvl4pPr marL="1371600" indent="0">
-              <a:buNone/>
-              <a:defRPr sz="2000"/>
-            </a:lvl4pPr>
-            <a:lvl5pPr marL="1828800" indent="0">
-              <a:buNone/>
-              <a:defRPr sz="2000"/>
-            </a:lvl5pPr>
-            <a:lvl6pPr marL="2286000" indent="0">
-              <a:buNone/>
-              <a:defRPr sz="2000"/>
-            </a:lvl6pPr>
-            <a:lvl7pPr marL="2743200" indent="0">
-              <a:buNone/>
-              <a:defRPr sz="2000"/>
-            </a:lvl7pPr>
-            <a:lvl8pPr marL="3200400" indent="0">
-              <a:buNone/>
-              <a:defRPr sz="2000"/>
-            </a:lvl8pPr>
-            <a:lvl9pPr marL="3657600" indent="0">
-              <a:buNone/>
-              <a:defRPr sz="2000"/>
-            </a:lvl9pPr>
-          </a:lstStyle>
-          <a:p>
-            <a:pPr lvl="0"/>
-            <a:endParaRPr lang="en-US" noProof="0"/>
-          </a:p>
-        </p:txBody>
-      </p:sp>
-      <p:sp>
-        <p:nvSpPr>
-          <p:cNvPr id="4" name="Text Placeholder 3"/>
-          <p:cNvSpPr>
-            <a:spLocks noGrp="1"/>
-          </p:cNvSpPr>
-          <p:nvPr>
-            <p:ph type="body" sz="half" idx="2"/>
-          </p:nvPr>
-        </p:nvSpPr>
-        <p:spPr>
-          <a:xfrm>
-            <a:off x="1792288" y="5367338"/>
-            <a:ext cx="5486400" cy="804862"/>
-          </a:xfrm>
-        </p:spPr>
-        <p:txBody>
-          <a:bodyPr/>
-          <a:lstStyle>
-            <a:lvl1pPr marL="0" indent="0">
-              <a:buNone/>
-              <a:defRPr sz="1400"/>
-            </a:lvl1pPr>
-            <a:lvl2pPr marL="457200" indent="0">
-              <a:buNone/>
-              <a:defRPr sz="1200"/>
-            </a:lvl2pPr>
-            <a:lvl3pPr marL="914400" indent="0">
-              <a:buNone/>
-              <a:defRPr sz="1000"/>
-            </a:lvl3pPr>
-            <a:lvl4pPr marL="1371600" indent="0">
-              <a:buNone/>
-              <a:defRPr sz="900"/>
-            </a:lvl4pPr>
-            <a:lvl5pPr marL="1828800" indent="0">
-              <a:buNone/>
-              <a:defRPr sz="900"/>
-            </a:lvl5pPr>
-            <a:lvl6pPr marL="2286000" indent="0">
-              <a:buNone/>
-              <a:defRPr sz="900"/>
-            </a:lvl6pPr>
-            <a:lvl7pPr marL="2743200" indent="0">
-              <a:buNone/>
-              <a:defRPr sz="900"/>
-            </a:lvl7pPr>
-            <a:lvl8pPr marL="3200400" indent="0">
-              <a:buNone/>
-              <a:defRPr sz="900"/>
-            </a:lvl8pPr>
-            <a:lvl9pPr marL="3657600" indent="0">
-              <a:buNone/>
-              <a:defRPr sz="900"/>
-            </a:lvl9pPr>
-          </a:lstStyle>
-          <a:p>
-            <a:pPr lvl="0"/>
-            <a:r>
-              <a:rPr lang="en-US"/>
-              <a:t>Click to edit Master text styles</a:t>
-            </a:r>
-          </a:p>
-        </p:txBody>
-      </p:sp>
-      <p:sp>
-        <p:nvSpPr>
-          <p:cNvPr id="5" name="Date Placeholder 3">
-            <a:extLst>
-              <a:ext uri="{FF2B5EF4-FFF2-40B4-BE49-F238E27FC236}">
-                <a16:creationId xmlns:a16="http://schemas.microsoft.com/office/drawing/2014/main" id="{AE467ABF-5DBD-0F44-6269-D1296B669355}"/>
-              </a:ext>
-            </a:extLst>
-          </p:cNvPr>
-          <p:cNvSpPr>
-            <a:spLocks noGrp="1"/>
-          </p:cNvSpPr>
-          <p:nvPr>
-            <p:ph type="dt" sz="half" idx="10"/>
-          </p:nvPr>
-        </p:nvSpPr>
-        <p:spPr/>
-        <p:txBody>
-          <a:bodyPr/>
-          <a:lstStyle>
-            <a:lvl1pPr>
-              <a:defRPr/>
-            </a:lvl1pPr>
-          </a:lstStyle>
-          <a:p>
-            <a:pPr>
-              <a:defRPr/>
-            </a:pPr>
-            <a:r>
-              <a:rPr lang="en-US"/>
-              <a:t>21/12/2020</a:t>
-            </a:r>
-          </a:p>
-        </p:txBody>
-      </p:sp>
-      <p:sp>
-        <p:nvSpPr>
-          <p:cNvPr id="6" name="Footer Placeholder 4">
-            <a:extLst>
-              <a:ext uri="{FF2B5EF4-FFF2-40B4-BE49-F238E27FC236}">
-                <a16:creationId xmlns:a16="http://schemas.microsoft.com/office/drawing/2014/main" id="{31729259-95EB-ABB4-8CC1-6AAA526DCDAA}"/>
-              </a:ext>
-            </a:extLst>
-          </p:cNvPr>
-          <p:cNvSpPr>
-            <a:spLocks noGrp="1"/>
-          </p:cNvSpPr>
-          <p:nvPr>
-            <p:ph type="ftr" sz="quarter" idx="11"/>
-          </p:nvPr>
-        </p:nvSpPr>
-        <p:spPr/>
-        <p:txBody>
-          <a:bodyPr/>
-          <a:lstStyle>
-            <a:lvl1pPr>
-              <a:defRPr/>
-            </a:lvl1pPr>
-          </a:lstStyle>
-          <a:p>
-            <a:pPr>
-              <a:defRPr/>
-            </a:pPr>
-            <a:endParaRPr lang="en-US"/>
-          </a:p>
-        </p:txBody>
-      </p:sp>
-      <p:sp>
-        <p:nvSpPr>
-          <p:cNvPr id="7" name="Slide Number Placeholder 5">
-            <a:extLst>
-              <a:ext uri="{FF2B5EF4-FFF2-40B4-BE49-F238E27FC236}">
-                <a16:creationId xmlns:a16="http://schemas.microsoft.com/office/drawing/2014/main" id="{762D7086-DF65-36F8-E6B6-082068B3EE8C}"/>
-              </a:ext>
-            </a:extLst>
-          </p:cNvPr>
-          <p:cNvSpPr>
-            <a:spLocks noGrp="1"/>
-          </p:cNvSpPr>
-          <p:nvPr>
-            <p:ph type="sldNum" sz="quarter" idx="12"/>
-          </p:nvPr>
-        </p:nvSpPr>
-        <p:spPr/>
-        <p:txBody>
-          <a:bodyPr/>
-          <a:lstStyle>
-            <a:lvl1pPr>
-              <a:defRPr/>
-            </a:lvl1pPr>
-          </a:lstStyle>
-          <a:p>
-            <a:pPr>
-              <a:defRPr/>
-            </a:pPr>
-            <a:fld id="{FB2052F0-E69A-488D-AA78-DE7ABB9591C3}" type="slidenum">
-              <a:rPr lang="en-US" altLang="en-US"/>
-              <a:pPr>
-                <a:defRPr/>
-              </a:pPr>
-              <a:t>‹#›</a:t>
-            </a:fld>
-            <a:endParaRPr lang="en-US" altLang="en-US"/>
-          </a:p>
-        </p:txBody>
-      </p:sp>
-    </p:spTree>
-    <p:extLst>
-      <p:ext uri="{BB962C8B-B14F-4D97-AF65-F5344CB8AC3E}">
-        <p14:creationId xmlns:p14="http://schemas.microsoft.com/office/powerpoint/2010/main" val="2265026697"/>
       </p:ext>
     </p:extLst>
   </p:cSld>
@@ -5443,17 +5508,17 @@
   <p:clrMap bg1="lt1" tx1="dk1" bg2="lt2" tx2="dk2" accent1="accent1" accent2="accent2" accent3="accent3" accent4="accent4" accent5="accent5" accent6="accent6" hlink="hlink" folHlink="folHlink"/>
   <p:sldLayoutIdLst>
     <p:sldLayoutId id="2147484833" r:id="rId1"/>
-    <p:sldLayoutId id="2147484834" r:id="rId2"/>
-    <p:sldLayoutId id="2147484835" r:id="rId3"/>
-    <p:sldLayoutId id="2147484836" r:id="rId4"/>
-    <p:sldLayoutId id="2147484837" r:id="rId5"/>
-    <p:sldLayoutId id="2147484838" r:id="rId6"/>
-    <p:sldLayoutId id="2147484839" r:id="rId7"/>
-    <p:sldLayoutId id="2147484840" r:id="rId8"/>
-    <p:sldLayoutId id="2147484841" r:id="rId9"/>
-    <p:sldLayoutId id="2147484842" r:id="rId10"/>
-    <p:sldLayoutId id="2147484843" r:id="rId11"/>
-    <p:sldLayoutId id="2147484844" r:id="rId12"/>
+    <p:sldLayoutId id="2147484844" r:id="rId2"/>
+    <p:sldLayoutId id="2147484834" r:id="rId3"/>
+    <p:sldLayoutId id="2147484835" r:id="rId4"/>
+    <p:sldLayoutId id="2147484836" r:id="rId5"/>
+    <p:sldLayoutId id="2147484837" r:id="rId6"/>
+    <p:sldLayoutId id="2147484838" r:id="rId7"/>
+    <p:sldLayoutId id="2147484839" r:id="rId8"/>
+    <p:sldLayoutId id="2147484840" r:id="rId9"/>
+    <p:sldLayoutId id="2147484841" r:id="rId10"/>
+    <p:sldLayoutId id="2147484842" r:id="rId11"/>
+    <p:sldLayoutId id="2147484843" r:id="rId12"/>
   </p:sldLayoutIdLst>
   <p:hf hdr="0" ftr="0"/>
   <p:txStyles>
@@ -6003,7 +6068,7 @@
           <a:p>
             <a:fld id="{B4B13859-67C5-4393-B6C2-556CF3F770C0}" type="datetime3">
               <a:rPr lang="en-US" smtClean="0"/>
-              <a:t>20 February 2026</a:t>
+              <a:t>23 February 2026</a:t>
             </a:fld>
             <a:endParaRPr lang="en-US" dirty="0"/>
           </a:p>
@@ -6556,37 +6621,8 @@
           <a:p>
             <a:fld id="{B4B13859-67C5-4393-B6C2-556CF3F770C0}" type="datetime3">
               <a:rPr lang="en-US" smtClean="0"/>
-              <a:t>20 February 2026</a:t>
+              <a:t>23 February 2026</a:t>
             </a:fld>
-            <a:endParaRPr lang="en-US" dirty="0"/>
-          </a:p>
-        </p:txBody>
-      </p:sp>
-      <p:sp>
-        <p:nvSpPr>
-          <p:cNvPr id="5" name="Footer Placeholder 4">
-            <a:extLst>
-              <a:ext uri="{FF2B5EF4-FFF2-40B4-BE49-F238E27FC236}">
-                <a16:creationId xmlns:a16="http://schemas.microsoft.com/office/drawing/2014/main" id="{5DA6DB8B-5424-AB6A-0274-1F3608CF68F2}"/>
-              </a:ext>
-            </a:extLst>
-          </p:cNvPr>
-          <p:cNvSpPr>
-            <a:spLocks noGrp="1"/>
-          </p:cNvSpPr>
-          <p:nvPr>
-            <p:ph type="ftr" sz="quarter" idx="11"/>
-          </p:nvPr>
-        </p:nvSpPr>
-        <p:spPr/>
-        <p:txBody>
-          <a:bodyPr/>
-          <a:lstStyle/>
-          <a:p>
-            <a:r>
-              <a:rPr lang="en-US"/>
-              <a:t>ELL305: Computer Architecture</a:t>
-            </a:r>
             <a:endParaRPr lang="en-US" dirty="0"/>
           </a:p>
         </p:txBody>
@@ -6841,7 +6877,7 @@
           <a:p>
             <a:fld id="{B4B13859-67C5-4393-B6C2-556CF3F770C0}" type="datetime3">
               <a:rPr lang="en-US" smtClean="0"/>
-              <a:t>20 February 2026</a:t>
+              <a:t>23 February 2026</a:t>
             </a:fld>
             <a:endParaRPr lang="en-US" dirty="0"/>
           </a:p>
@@ -7048,7 +7084,7 @@
           <p:cNvPr id="2" name="Title 1">
             <a:extLst>
               <a:ext uri="{FF2B5EF4-FFF2-40B4-BE49-F238E27FC236}">
-                <a16:creationId xmlns:a16="http://schemas.microsoft.com/office/drawing/2014/main" id="{BF421145-0DE4-3ECF-C2A1-855B26F8C15A}"/>
+                <a16:creationId xmlns:a16="http://schemas.microsoft.com/office/drawing/2014/main" id="{A3231187-F125-67D0-E4BE-0A4039CA85CB}"/>
               </a:ext>
             </a:extLst>
           </p:cNvPr>
@@ -7066,75 +7102,95 @@
           <a:p>
             <a:r>
               <a:rPr lang="en-US" dirty="0"/>
-              <a:t>Pipelined RISC-V processor</a:t>
-            </a:r>
+              <a:t>Pipelined </a:t>
+            </a:r>
+            <a:r>
+              <a:rPr lang="en-US" dirty="0" err="1"/>
+              <a:t>datapath</a:t>
+            </a:r>
+            <a:r>
+              <a:rPr lang="en-US" dirty="0"/>
+              <a:t> and control</a:t>
+            </a:r>
+            <a:endParaRPr lang="en-IN" dirty="0"/>
           </a:p>
         </p:txBody>
       </p:sp>
-      <p:sp>
-        <p:nvSpPr>
-          <p:cNvPr id="4" name="Date Placeholder 3">
+      <p:pic>
+        <p:nvPicPr>
+          <p:cNvPr id="7" name="Content Placeholder 6">
             <a:extLst>
               <a:ext uri="{FF2B5EF4-FFF2-40B4-BE49-F238E27FC236}">
-                <a16:creationId xmlns:a16="http://schemas.microsoft.com/office/drawing/2014/main" id="{1D2AE603-7286-AAEA-CFE4-1DDF5B37938C}"/>
+                <a16:creationId xmlns:a16="http://schemas.microsoft.com/office/drawing/2014/main" id="{93CCBE13-FF4F-9854-0ECC-2664C6AC9C85}"/>
               </a:ext>
             </a:extLst>
           </p:cNvPr>
-          <p:cNvSpPr>
-            <a:spLocks noGrp="1"/>
-          </p:cNvSpPr>
+          <p:cNvPicPr>
+            <a:picLocks noGrp="1" noChangeAspect="1"/>
+          </p:cNvPicPr>
           <p:nvPr>
-            <p:ph type="dt" sz="half" idx="10"/>
+            <p:ph idx="1"/>
           </p:nvPr>
-        </p:nvSpPr>
-        <p:spPr/>
-        <p:txBody>
-          <a:bodyPr/>
-          <a:lstStyle/>
-          <a:p>
-            <a:fld id="{B4B13859-67C5-4393-B6C2-556CF3F770C0}" type="datetime3">
-              <a:rPr lang="en-US" smtClean="0"/>
-              <a:t>20 February 2026</a:t>
-            </a:fld>
-            <a:endParaRPr lang="en-US"/>
-          </a:p>
-        </p:txBody>
-      </p:sp>
+        </p:nvPicPr>
+        <p:blipFill>
+          <a:blip r:embed="rId2">
+            <a:extLst>
+              <a:ext uri="{BEBA8EAE-BF5A-486C-A8C5-ECC9F3942E4B}">
+                <a14:imgProps xmlns:a14="http://schemas.microsoft.com/office/drawing/2010/main">
+                  <a14:imgLayer r:embed="rId3">
+                    <a14:imgEffect>
+                      <a14:artisticPhotocopy trans="54000"/>
+                    </a14:imgEffect>
+                  </a14:imgLayer>
+                </a14:imgProps>
+              </a:ext>
+              <a:ext uri="{28A0092B-C50C-407E-A947-70E740481C1C}">
+                <a14:useLocalDpi xmlns:a14="http://schemas.microsoft.com/office/drawing/2010/main" val="0"/>
+              </a:ext>
+            </a:extLst>
+          </a:blip>
+          <a:srcRect/>
+          <a:stretch/>
+        </p:blipFill>
+        <p:spPr bwMode="auto">
+          <a:xfrm>
+            <a:off x="152400" y="1513399"/>
+            <a:ext cx="8839200" cy="4880540"/>
+          </a:xfrm>
+          <a:prstGeom prst="rect">
+            <a:avLst/>
+          </a:prstGeom>
+          <a:noFill/>
+          <a:ln>
+            <a:noFill/>
+          </a:ln>
+          <a:extLst>
+            <a:ext uri="{909E8E84-426E-40DD-AFC4-6F175D3DCCD1}">
+              <a14:hiddenFill xmlns:a14="http://schemas.microsoft.com/office/drawing/2010/main">
+                <a:solidFill>
+                  <a:srgbClr val="FFFFFF"/>
+                </a:solidFill>
+              </a14:hiddenFill>
+            </a:ext>
+            <a:ext uri="{91240B29-F687-4F45-9708-019B960494DF}">
+              <a14:hiddenLine xmlns:a14="http://schemas.microsoft.com/office/drawing/2010/main" w="9525">
+                <a:solidFill>
+                  <a:srgbClr val="000000"/>
+                </a:solidFill>
+                <a:miter lim="800000"/>
+                <a:headEnd/>
+                <a:tailEnd/>
+              </a14:hiddenLine>
+            </a:ext>
+          </a:extLst>
+        </p:spPr>
+      </p:pic>
       <p:sp>
         <p:nvSpPr>
-          <p:cNvPr id="5" name="Footer Placeholder 4">
+          <p:cNvPr id="5" name="Slide Number Placeholder 4">
             <a:extLst>
               <a:ext uri="{FF2B5EF4-FFF2-40B4-BE49-F238E27FC236}">
-                <a16:creationId xmlns:a16="http://schemas.microsoft.com/office/drawing/2014/main" id="{49E0A889-A928-F0A5-E3F6-4B4680CF3E8F}"/>
-              </a:ext>
-            </a:extLst>
-          </p:cNvPr>
-          <p:cNvSpPr>
-            <a:spLocks noGrp="1"/>
-          </p:cNvSpPr>
-          <p:nvPr>
-            <p:ph type="ftr" sz="quarter" idx="11"/>
-          </p:nvPr>
-        </p:nvSpPr>
-        <p:spPr/>
-        <p:txBody>
-          <a:bodyPr/>
-          <a:lstStyle/>
-          <a:p>
-            <a:r>
-              <a:rPr lang="en-US"/>
-              <a:t>ELL305: Computer Architecture</a:t>
-            </a:r>
-            <a:endParaRPr lang="en-US" dirty="0"/>
-          </a:p>
-        </p:txBody>
-      </p:sp>
-      <p:sp>
-        <p:nvSpPr>
-          <p:cNvPr id="6" name="Slide Number Placeholder 5">
-            <a:extLst>
-              <a:ext uri="{FF2B5EF4-FFF2-40B4-BE49-F238E27FC236}">
-                <a16:creationId xmlns:a16="http://schemas.microsoft.com/office/drawing/2014/main" id="{B29DA800-094F-054A-F73D-3A4A2DA7C0E2}"/>
+                <a16:creationId xmlns:a16="http://schemas.microsoft.com/office/drawing/2014/main" id="{F28D89EB-2DF1-71E4-CD5C-E9986CEA56FD}"/>
               </a:ext>
             </a:extLst>
           </p:cNvPr>
@@ -7150,49 +7206,26 @@
           <a:bodyPr/>
           <a:lstStyle/>
           <a:p>
-            <a:fld id="{98AC3541-01C1-4CA5-B68F-FEE868C7D1AF}" type="slidenum">
-              <a:rPr lang="en-US" smtClean="0"/>
+            <a:pPr>
+              <a:defRPr/>
+            </a:pPr>
+            <a:fld id="{CA887A73-1AE0-46F8-856A-18EA1CF30A1B}" type="slidenum">
+              <a:rPr lang="en-US" altLang="en-US" smtClean="0"/>
+              <a:pPr>
+                <a:defRPr/>
+              </a:pPr>
               <a:t>13</a:t>
             </a:fld>
-            <a:endParaRPr lang="en-US"/>
+            <a:endParaRPr lang="en-US" altLang="en-US"/>
           </a:p>
         </p:txBody>
       </p:sp>
-      <p:pic>
-        <p:nvPicPr>
-          <p:cNvPr id="14" name="Content Placeholder 13">
+      <p:sp>
+        <p:nvSpPr>
+          <p:cNvPr id="8" name="TextBox 7">
             <a:extLst>
               <a:ext uri="{FF2B5EF4-FFF2-40B4-BE49-F238E27FC236}">
-                <a16:creationId xmlns:a16="http://schemas.microsoft.com/office/drawing/2014/main" id="{A1217202-A09F-5322-DA26-C55378F03E62}"/>
-              </a:ext>
-            </a:extLst>
-          </p:cNvPr>
-          <p:cNvPicPr>
-            <a:picLocks noGrp="1" noChangeAspect="1"/>
-          </p:cNvPicPr>
-          <p:nvPr>
-            <p:ph idx="1"/>
-          </p:nvPr>
-        </p:nvPicPr>
-        <p:blipFill>
-          <a:blip r:embed="rId2"/>
-          <a:stretch>
-            <a:fillRect/>
-          </a:stretch>
-        </p:blipFill>
-        <p:spPr>
-          <a:xfrm>
-            <a:off x="801943" y="1368029"/>
-            <a:ext cx="7557815" cy="3963591"/>
-          </a:xfrm>
-        </p:spPr>
-      </p:pic>
-      <p:sp>
-        <p:nvSpPr>
-          <p:cNvPr id="18" name="TextBox 17">
-            <a:extLst>
-              <a:ext uri="{FF2B5EF4-FFF2-40B4-BE49-F238E27FC236}">
-                <a16:creationId xmlns:a16="http://schemas.microsoft.com/office/drawing/2014/main" id="{6E8367E8-1DDA-EF87-332F-074D02336297}"/>
+                <a16:creationId xmlns:a16="http://schemas.microsoft.com/office/drawing/2014/main" id="{73382E28-74AC-31C7-2628-52B3C11FCD7D}"/>
               </a:ext>
             </a:extLst>
           </p:cNvPr>
@@ -7201,8 +7234,8 @@
         </p:nvSpPr>
         <p:spPr>
           <a:xfrm>
-            <a:off x="72866" y="5318117"/>
-            <a:ext cx="4586288" cy="415498"/>
+            <a:off x="4724400" y="1274243"/>
+            <a:ext cx="4419600" cy="415498"/>
           </a:xfrm>
           <a:prstGeom prst="rect">
             <a:avLst/>
@@ -7226,10 +7259,44 @@
           </a:p>
         </p:txBody>
       </p:sp>
+      <p:sp>
+        <p:nvSpPr>
+          <p:cNvPr id="3" name="Date Placeholder 3">
+            <a:extLst>
+              <a:ext uri="{FF2B5EF4-FFF2-40B4-BE49-F238E27FC236}">
+                <a16:creationId xmlns:a16="http://schemas.microsoft.com/office/drawing/2014/main" id="{A57F0CFA-E06B-262D-1617-BEDA17B2CABF}"/>
+              </a:ext>
+            </a:extLst>
+          </p:cNvPr>
+          <p:cNvSpPr>
+            <a:spLocks noGrp="1"/>
+          </p:cNvSpPr>
+          <p:nvPr>
+            <p:ph type="dt" sz="half" idx="10"/>
+          </p:nvPr>
+        </p:nvSpPr>
+        <p:spPr>
+          <a:xfrm>
+            <a:off x="0" y="6599238"/>
+            <a:ext cx="1828800" cy="258762"/>
+          </a:xfrm>
+        </p:spPr>
+        <p:txBody>
+          <a:bodyPr/>
+          <a:lstStyle/>
+          <a:p>
+            <a:fld id="{B4B13859-67C5-4393-B6C2-556CF3F770C0}" type="datetime3">
+              <a:rPr lang="en-US" smtClean="0"/>
+              <a:t>23 February 2026</a:t>
+            </a:fld>
+            <a:endParaRPr lang="en-US" dirty="0"/>
+          </a:p>
+        </p:txBody>
+      </p:sp>
     </p:spTree>
     <p:extLst>
       <p:ext uri="{BB962C8B-B14F-4D97-AF65-F5344CB8AC3E}">
-        <p14:creationId xmlns:p14="http://schemas.microsoft.com/office/powerpoint/2010/main" val="553420517"/>
+        <p14:creationId xmlns:p14="http://schemas.microsoft.com/office/powerpoint/2010/main" val="689940020"/>
       </p:ext>
     </p:extLst>
   </p:cSld>
@@ -7270,7 +7337,7 @@
                                           </p:stCondLst>
                                         </p:cTn>
                                         <p:tgtEl>
-                                          <p:spTgt spid="18"/>
+                                          <p:spTgt spid="8"/>
                                         </p:tgtEl>
                                         <p:attrNameLst>
                                           <p:attrName>style.visibility</p:attrName>
@@ -7311,7 +7378,7 @@
       </p:par>
     </p:tnLst>
     <p:bldLst>
-      <p:bldP spid="18" grpId="0"/>
+      <p:bldP spid="8" grpId="0"/>
     </p:bldLst>
   </p:timing>
 </p:sld>
@@ -7492,37 +7559,8 @@
           <a:p>
             <a:fld id="{B4B13859-67C5-4393-B6C2-556CF3F770C0}" type="datetime3">
               <a:rPr lang="en-US" smtClean="0"/>
-              <a:t>20 February 2026</a:t>
+              <a:t>23 February 2026</a:t>
             </a:fld>
-            <a:endParaRPr lang="en-US"/>
-          </a:p>
-        </p:txBody>
-      </p:sp>
-      <p:sp>
-        <p:nvSpPr>
-          <p:cNvPr id="5" name="Footer Placeholder 4">
-            <a:extLst>
-              <a:ext uri="{FF2B5EF4-FFF2-40B4-BE49-F238E27FC236}">
-                <a16:creationId xmlns:a16="http://schemas.microsoft.com/office/drawing/2014/main" id="{61D822FE-DDD3-4641-39F1-147E0BAC9EFC}"/>
-              </a:ext>
-            </a:extLst>
-          </p:cNvPr>
-          <p:cNvSpPr>
-            <a:spLocks noGrp="1"/>
-          </p:cNvSpPr>
-          <p:nvPr>
-            <p:ph type="ftr" sz="quarter" idx="11"/>
-          </p:nvPr>
-        </p:nvSpPr>
-        <p:spPr/>
-        <p:txBody>
-          <a:bodyPr/>
-          <a:lstStyle/>
-          <a:p>
-            <a:r>
-              <a:rPr lang="en-US"/>
-              <a:t>ELL305: Computer Architecture</a:t>
-            </a:r>
             <a:endParaRPr lang="en-US" dirty="0"/>
           </a:p>
         </p:txBody>
@@ -7632,45 +7670,36 @@
         </p:nvSpPr>
         <p:spPr>
           <a:xfrm>
-            <a:off x="94576" y="1609808"/>
-            <a:ext cx="2871510" cy="4790991"/>
+            <a:off x="97533" y="1459583"/>
+            <a:ext cx="2871510" cy="4943392"/>
           </a:xfrm>
         </p:spPr>
         <p:txBody>
           <a:bodyPr>
-            <a:normAutofit fontScale="55000" lnSpcReduction="20000"/>
+            <a:noAutofit/>
           </a:bodyPr>
           <a:lstStyle/>
           <a:p>
             <a:r>
-              <a:rPr lang="en-US" dirty="0"/>
+              <a:rPr lang="en-US" sz="2000" dirty="0"/>
               <a:t>Problem: Two or more instructions in the pipeline compete for access to a single physical resource</a:t>
             </a:r>
           </a:p>
           <a:p>
-            <a:endParaRPr lang="en-US" dirty="0"/>
-          </a:p>
-          <a:p>
-            <a:r>
-              <a:rPr lang="en-US" dirty="0"/>
+            <a:r>
+              <a:rPr lang="en-US" sz="2000" dirty="0"/>
               <a:t>Solution 1: Instructions take turns using resource, some instructions have to stall (wait)</a:t>
             </a:r>
           </a:p>
           <a:p>
-            <a:endParaRPr lang="en-US" dirty="0"/>
-          </a:p>
-          <a:p>
-            <a:r>
-              <a:rPr lang="en-US" dirty="0"/>
+            <a:r>
+              <a:rPr lang="en-US" sz="2000" dirty="0"/>
               <a:t>Solution 2: Add more hardware to machine</a:t>
             </a:r>
           </a:p>
           <a:p>
-            <a:endParaRPr lang="en-US" dirty="0"/>
-          </a:p>
-          <a:p>
-            <a:r>
-              <a:rPr lang="en-US" dirty="0"/>
+            <a:r>
+              <a:rPr lang="en-US" sz="2000" dirty="0"/>
               <a:t>Can always solve a structural hazard by adding more hardware</a:t>
             </a:r>
           </a:p>
@@ -7699,37 +7728,9 @@
           <a:p>
             <a:fld id="{B4B13859-67C5-4393-B6C2-556CF3F770C0}" type="datetime3">
               <a:rPr lang="en-US" smtClean="0"/>
-              <a:t>20 February 2026</a:t>
+              <a:t>23 February 2026</a:t>
             </a:fld>
             <a:endParaRPr lang="en-US"/>
-          </a:p>
-        </p:txBody>
-      </p:sp>
-      <p:sp>
-        <p:nvSpPr>
-          <p:cNvPr id="5" name="Footer Placeholder 4">
-            <a:extLst>
-              <a:ext uri="{FF2B5EF4-FFF2-40B4-BE49-F238E27FC236}">
-                <a16:creationId xmlns:a16="http://schemas.microsoft.com/office/drawing/2014/main" id="{29D49AD5-BD30-F00E-BBA7-646FB48132C9}"/>
-              </a:ext>
-            </a:extLst>
-          </p:cNvPr>
-          <p:cNvSpPr>
-            <a:spLocks noGrp="1"/>
-          </p:cNvSpPr>
-          <p:nvPr>
-            <p:ph type="ftr" sz="quarter" idx="11"/>
-          </p:nvPr>
-        </p:nvSpPr>
-        <p:spPr/>
-        <p:txBody>
-          <a:bodyPr/>
-          <a:lstStyle/>
-          <a:p>
-            <a:r>
-              <a:rPr lang="en-US" dirty="0"/>
-              <a:t>ELL305: Computer Architecture</a:t>
-            </a:r>
           </a:p>
         </p:txBody>
       </p:sp>
@@ -7784,8 +7785,8 @@
         </p:blipFill>
         <p:spPr>
           <a:xfrm>
-            <a:off x="3124200" y="1609808"/>
-            <a:ext cx="3372050" cy="2049902"/>
+            <a:off x="2969043" y="1579322"/>
+            <a:ext cx="3733800" cy="2269813"/>
           </a:xfrm>
           <a:prstGeom prst="rect">
             <a:avLst/>
@@ -7857,8 +7858,8 @@
         </p:blipFill>
         <p:spPr>
           <a:xfrm>
-            <a:off x="2971800" y="4179097"/>
-            <a:ext cx="3372050" cy="2069303"/>
+            <a:off x="2966415" y="3968874"/>
+            <a:ext cx="3733799" cy="2291295"/>
           </a:xfrm>
           <a:prstGeom prst="rect">
             <a:avLst/>
@@ -8299,7 +8300,7 @@
                                         <p:tgtEl>
                                           <p:spTgt spid="3">
                                             <p:txEl>
-                                              <p:pRg st="2" end="2"/>
+                                              <p:pRg st="1" end="1"/>
                                             </p:txEl>
                                           </p:spTgt>
                                         </p:tgtEl>
@@ -8348,7 +8349,7 @@
                                         <p:tgtEl>
                                           <p:spTgt spid="3">
                                             <p:txEl>
-                                              <p:pRg st="4" end="4"/>
+                                              <p:pRg st="2" end="2"/>
                                             </p:txEl>
                                           </p:spTgt>
                                         </p:tgtEl>
@@ -8397,7 +8398,7 @@
                                         <p:tgtEl>
                                           <p:spTgt spid="3">
                                             <p:txEl>
-                                              <p:pRg st="6" end="6"/>
+                                              <p:pRg st="3" end="3"/>
                                             </p:txEl>
                                           </p:spTgt>
                                         </p:tgtEl>
@@ -8448,6 +8449,2729 @@
 </p:sld>
 </file>
 
+<file path=ppt/slides/slide16.xml><?xml version="1.0" encoding="utf-8"?>
+<p:sld xmlns:a="http://schemas.openxmlformats.org/drawingml/2006/main" xmlns:r="http://schemas.openxmlformats.org/officeDocument/2006/relationships" xmlns:p="http://schemas.openxmlformats.org/presentationml/2006/main">
+  <p:cSld>
+    <p:spTree>
+      <p:nvGrpSpPr>
+        <p:cNvPr id="1" name=""/>
+        <p:cNvGrpSpPr/>
+        <p:nvPr/>
+      </p:nvGrpSpPr>
+      <p:grpSpPr>
+        <a:xfrm>
+          <a:off x="0" y="0"/>
+          <a:ext cx="0" cy="0"/>
+          <a:chOff x="0" y="0"/>
+          <a:chExt cx="0" cy="0"/>
+        </a:xfrm>
+      </p:grpSpPr>
+      <p:grpSp>
+        <p:nvGrpSpPr>
+          <p:cNvPr id="11" name="Group 10">
+            <a:extLst>
+              <a:ext uri="{FF2B5EF4-FFF2-40B4-BE49-F238E27FC236}">
+                <a16:creationId xmlns:a16="http://schemas.microsoft.com/office/drawing/2014/main" id="{C4922366-B05A-61C2-398D-CEECE9561EFE}"/>
+              </a:ext>
+            </a:extLst>
+          </p:cNvPr>
+          <p:cNvGrpSpPr/>
+          <p:nvPr/>
+        </p:nvGrpSpPr>
+        <p:grpSpPr>
+          <a:xfrm>
+            <a:off x="2841441" y="1464049"/>
+            <a:ext cx="5921559" cy="3700749"/>
+            <a:chOff x="2841441" y="1464049"/>
+            <a:chExt cx="5921559" cy="3700749"/>
+          </a:xfrm>
+        </p:grpSpPr>
+        <p:pic>
+          <p:nvPicPr>
+            <p:cNvPr id="3" name="Picture 2">
+              <a:extLst>
+                <a:ext uri="{FF2B5EF4-FFF2-40B4-BE49-F238E27FC236}">
+                  <a16:creationId xmlns:a16="http://schemas.microsoft.com/office/drawing/2014/main" id="{BF7C7CF1-2221-266A-D5DE-1DE59E6E5747}"/>
+                </a:ext>
+              </a:extLst>
+            </p:cNvPr>
+            <p:cNvPicPr>
+              <a:picLocks noChangeAspect="1"/>
+            </p:cNvPicPr>
+            <p:nvPr/>
+          </p:nvPicPr>
+          <p:blipFill>
+            <a:blip r:embed="rId2"/>
+            <a:srcRect t="2" r="17410" b="-529"/>
+            <a:stretch>
+              <a:fillRect/>
+            </a:stretch>
+          </p:blipFill>
+          <p:spPr>
+            <a:xfrm>
+              <a:off x="2841441" y="1464049"/>
+              <a:ext cx="5159560" cy="3641351"/>
+            </a:xfrm>
+            <a:prstGeom prst="rect">
+              <a:avLst/>
+            </a:prstGeom>
+          </p:spPr>
+        </p:pic>
+        <p:pic>
+          <p:nvPicPr>
+            <p:cNvPr id="9" name="Picture 8">
+              <a:extLst>
+                <a:ext uri="{FF2B5EF4-FFF2-40B4-BE49-F238E27FC236}">
+                  <a16:creationId xmlns:a16="http://schemas.microsoft.com/office/drawing/2014/main" id="{1300C606-CD95-DD41-93FE-F11419095FFD}"/>
+                </a:ext>
+              </a:extLst>
+            </p:cNvPr>
+            <p:cNvPicPr>
+              <a:picLocks noChangeAspect="1"/>
+            </p:cNvPicPr>
+            <p:nvPr/>
+          </p:nvPicPr>
+          <p:blipFill>
+            <a:blip r:embed="rId3"/>
+            <a:stretch>
+              <a:fillRect/>
+            </a:stretch>
+          </p:blipFill>
+          <p:spPr>
+            <a:xfrm>
+              <a:off x="5414595" y="2903538"/>
+              <a:ext cx="3348405" cy="2261260"/>
+            </a:xfrm>
+            <a:prstGeom prst="rect">
+              <a:avLst/>
+            </a:prstGeom>
+          </p:spPr>
+        </p:pic>
+      </p:grpSp>
+      <p:sp>
+        <p:nvSpPr>
+          <p:cNvPr id="2" name="Title 1">
+            <a:extLst>
+              <a:ext uri="{FF2B5EF4-FFF2-40B4-BE49-F238E27FC236}">
+                <a16:creationId xmlns:a16="http://schemas.microsoft.com/office/drawing/2014/main" id="{769AAB66-7D67-15C6-E864-827A2D021380}"/>
+              </a:ext>
+            </a:extLst>
+          </p:cNvPr>
+          <p:cNvSpPr>
+            <a:spLocks noGrp="1"/>
+          </p:cNvSpPr>
+          <p:nvPr>
+            <p:ph type="title"/>
+          </p:nvPr>
+        </p:nvSpPr>
+        <p:spPr/>
+        <p:txBody>
+          <a:bodyPr/>
+          <a:lstStyle/>
+          <a:p>
+            <a:r>
+              <a:rPr lang="en-US" dirty="0"/>
+              <a:t>Data hazards</a:t>
+            </a:r>
+          </a:p>
+        </p:txBody>
+      </p:sp>
+      <p:pic>
+        <p:nvPicPr>
+          <p:cNvPr id="8" name="Content Placeholder 7">
+            <a:extLst>
+              <a:ext uri="{FF2B5EF4-FFF2-40B4-BE49-F238E27FC236}">
+                <a16:creationId xmlns:a16="http://schemas.microsoft.com/office/drawing/2014/main" id="{5C90681D-9ADB-9A6A-0188-3CAAC9CF0C06}"/>
+              </a:ext>
+            </a:extLst>
+          </p:cNvPr>
+          <p:cNvPicPr>
+            <a:picLocks noGrp="1" noChangeAspect="1"/>
+          </p:cNvPicPr>
+          <p:nvPr>
+            <p:ph idx="1"/>
+          </p:nvPr>
+        </p:nvPicPr>
+        <p:blipFill rotWithShape="1">
+          <a:blip r:embed="rId4"/>
+          <a:srcRect l="27599" t="15255" r="13066"/>
+          <a:stretch/>
+        </p:blipFill>
+        <p:spPr>
+          <a:xfrm>
+            <a:off x="94575" y="1464049"/>
+            <a:ext cx="3011805" cy="2237423"/>
+          </a:xfrm>
+        </p:spPr>
+      </p:pic>
+      <p:sp>
+        <p:nvSpPr>
+          <p:cNvPr id="4" name="Date Placeholder 3">
+            <a:extLst>
+              <a:ext uri="{FF2B5EF4-FFF2-40B4-BE49-F238E27FC236}">
+                <a16:creationId xmlns:a16="http://schemas.microsoft.com/office/drawing/2014/main" id="{B2BC43D6-C103-542A-D3A6-CF6A6D60FEFE}"/>
+              </a:ext>
+            </a:extLst>
+          </p:cNvPr>
+          <p:cNvSpPr>
+            <a:spLocks noGrp="1"/>
+          </p:cNvSpPr>
+          <p:nvPr>
+            <p:ph type="dt" sz="half" idx="10"/>
+          </p:nvPr>
+        </p:nvSpPr>
+        <p:spPr/>
+        <p:txBody>
+          <a:bodyPr/>
+          <a:lstStyle/>
+          <a:p>
+            <a:fld id="{B4B13859-67C5-4393-B6C2-556CF3F770C0}" type="datetime3">
+              <a:rPr lang="en-US" smtClean="0"/>
+              <a:t>23 February 2026</a:t>
+            </a:fld>
+            <a:endParaRPr lang="en-US"/>
+          </a:p>
+        </p:txBody>
+      </p:sp>
+      <p:sp>
+        <p:nvSpPr>
+          <p:cNvPr id="6" name="Slide Number Placeholder 5">
+            <a:extLst>
+              <a:ext uri="{FF2B5EF4-FFF2-40B4-BE49-F238E27FC236}">
+                <a16:creationId xmlns:a16="http://schemas.microsoft.com/office/drawing/2014/main" id="{2F58CFCF-8205-BC7F-6CB8-5FFFBDEFF171}"/>
+              </a:ext>
+            </a:extLst>
+          </p:cNvPr>
+          <p:cNvSpPr>
+            <a:spLocks noGrp="1"/>
+          </p:cNvSpPr>
+          <p:nvPr>
+            <p:ph type="sldNum" sz="quarter" idx="12"/>
+          </p:nvPr>
+        </p:nvSpPr>
+        <p:spPr/>
+        <p:txBody>
+          <a:bodyPr/>
+          <a:lstStyle/>
+          <a:p>
+            <a:fld id="{98AC3541-01C1-4CA5-B68F-FEE868C7D1AF}" type="slidenum">
+              <a:rPr lang="en-US" smtClean="0"/>
+              <a:t>16</a:t>
+            </a:fld>
+            <a:endParaRPr lang="en-US"/>
+          </a:p>
+        </p:txBody>
+      </p:sp>
+      <p:pic>
+        <p:nvPicPr>
+          <p:cNvPr id="10" name="Picture 9">
+            <a:extLst>
+              <a:ext uri="{FF2B5EF4-FFF2-40B4-BE49-F238E27FC236}">
+                <a16:creationId xmlns:a16="http://schemas.microsoft.com/office/drawing/2014/main" id="{AA41F6F8-CEC2-30D7-7364-8CCAF876191C}"/>
+              </a:ext>
+            </a:extLst>
+          </p:cNvPr>
+          <p:cNvPicPr>
+            <a:picLocks noChangeAspect="1"/>
+          </p:cNvPicPr>
+          <p:nvPr/>
+        </p:nvPicPr>
+        <p:blipFill>
+          <a:blip r:embed="rId2"/>
+          <a:srcRect b="70997"/>
+          <a:stretch>
+            <a:fillRect/>
+          </a:stretch>
+        </p:blipFill>
+        <p:spPr>
+          <a:xfrm>
+            <a:off x="2841440" y="1464049"/>
+            <a:ext cx="6247185" cy="1050551"/>
+          </a:xfrm>
+          <a:prstGeom prst="rect">
+            <a:avLst/>
+          </a:prstGeom>
+        </p:spPr>
+      </p:pic>
+      <p:sp>
+        <p:nvSpPr>
+          <p:cNvPr id="12" name="TextBox 11">
+            <a:extLst>
+              <a:ext uri="{FF2B5EF4-FFF2-40B4-BE49-F238E27FC236}">
+                <a16:creationId xmlns:a16="http://schemas.microsoft.com/office/drawing/2014/main" id="{4037BDD5-40E0-1C83-CAAC-852AD2B1CA8F}"/>
+              </a:ext>
+            </a:extLst>
+          </p:cNvPr>
+          <p:cNvSpPr txBox="1"/>
+          <p:nvPr/>
+        </p:nvSpPr>
+        <p:spPr>
+          <a:xfrm>
+            <a:off x="152400" y="3926670"/>
+            <a:ext cx="4100036" cy="2585323"/>
+          </a:xfrm>
+          <a:prstGeom prst="rect">
+            <a:avLst/>
+          </a:prstGeom>
+          <a:noFill/>
+        </p:spPr>
+        <p:txBody>
+          <a:bodyPr wrap="square">
+            <a:spAutoFit/>
+          </a:bodyPr>
+          <a:lstStyle/>
+          <a:p>
+            <a:pPr marL="214313" indent="-214313">
+              <a:buFont typeface="Arial" panose="020B0604020202020204" pitchFamily="34" charset="0"/>
+              <a:buChar char="•"/>
+            </a:pPr>
+            <a:r>
+              <a:rPr lang="en-US" dirty="0">
+                <a:solidFill>
+                  <a:srgbClr val="FFC000"/>
+                </a:solidFill>
+              </a:rPr>
+              <a:t>RAW: Read After Write </a:t>
+            </a:r>
+            <a:r>
+              <a:rPr lang="en-US" dirty="0"/>
+              <a:t>(instruction tries to read before previous instruction has finished writing)</a:t>
+            </a:r>
+          </a:p>
+          <a:p>
+            <a:pPr marL="214313" indent="-214313">
+              <a:buFont typeface="Arial" panose="020B0604020202020204" pitchFamily="34" charset="0"/>
+              <a:buChar char="•"/>
+            </a:pPr>
+            <a:r>
+              <a:rPr lang="en-US" dirty="0">
+                <a:solidFill>
+                  <a:srgbClr val="FFC000"/>
+                </a:solidFill>
+              </a:rPr>
+              <a:t>WAR: Write After Read </a:t>
+            </a:r>
+            <a:r>
+              <a:rPr lang="en-US" dirty="0"/>
+              <a:t>(instruction writes to a register before a previous instruction has read from it)</a:t>
+            </a:r>
+          </a:p>
+          <a:p>
+            <a:pPr marL="214313" indent="-214313">
+              <a:buFont typeface="Arial" panose="020B0604020202020204" pitchFamily="34" charset="0"/>
+              <a:buChar char="•"/>
+            </a:pPr>
+            <a:r>
+              <a:rPr lang="en-US" dirty="0">
+                <a:solidFill>
+                  <a:srgbClr val="FFC000"/>
+                </a:solidFill>
+              </a:rPr>
+              <a:t>WAW: Write After Write </a:t>
+            </a:r>
+            <a:r>
+              <a:rPr lang="en-US" dirty="0"/>
+              <a:t>(instruction writes to a register before an earlier instruction writes to it)</a:t>
+            </a:r>
+          </a:p>
+        </p:txBody>
+      </p:sp>
+      <p:sp>
+        <p:nvSpPr>
+          <p:cNvPr id="13" name="Rectangle 12">
+            <a:extLst>
+              <a:ext uri="{FF2B5EF4-FFF2-40B4-BE49-F238E27FC236}">
+                <a16:creationId xmlns:a16="http://schemas.microsoft.com/office/drawing/2014/main" id="{B17C58D4-998D-B653-EBE9-881AEDF63DBF}"/>
+              </a:ext>
+            </a:extLst>
+          </p:cNvPr>
+          <p:cNvSpPr/>
+          <p:nvPr/>
+        </p:nvSpPr>
+        <p:spPr>
+          <a:xfrm>
+            <a:off x="6172200" y="3523861"/>
+            <a:ext cx="381000" cy="228600"/>
+          </a:xfrm>
+          <a:prstGeom prst="rect">
+            <a:avLst/>
+          </a:prstGeom>
+          <a:noFill/>
+          <a:ln w="38100">
+            <a:solidFill>
+              <a:srgbClr val="FF0000"/>
+            </a:solidFill>
+          </a:ln>
+        </p:spPr>
+        <p:style>
+          <a:lnRef idx="2">
+            <a:schemeClr val="accent6"/>
+          </a:lnRef>
+          <a:fillRef idx="1">
+            <a:schemeClr val="lt1"/>
+          </a:fillRef>
+          <a:effectRef idx="0">
+            <a:schemeClr val="accent6"/>
+          </a:effectRef>
+          <a:fontRef idx="minor">
+            <a:schemeClr val="dk1"/>
+          </a:fontRef>
+        </p:style>
+        <p:txBody>
+          <a:bodyPr rtlCol="0" anchor="ctr"/>
+          <a:lstStyle/>
+          <a:p>
+            <a:pPr algn="ctr"/>
+            <a:endParaRPr lang="en-IN"/>
+          </a:p>
+        </p:txBody>
+      </p:sp>
+      <p:sp>
+        <p:nvSpPr>
+          <p:cNvPr id="14" name="Rectangle 13">
+            <a:extLst>
+              <a:ext uri="{FF2B5EF4-FFF2-40B4-BE49-F238E27FC236}">
+                <a16:creationId xmlns:a16="http://schemas.microsoft.com/office/drawing/2014/main" id="{D712CA9C-B126-9270-E66B-BB7AC7DFBE6C}"/>
+              </a:ext>
+            </a:extLst>
+          </p:cNvPr>
+          <p:cNvSpPr/>
+          <p:nvPr/>
+        </p:nvSpPr>
+        <p:spPr>
+          <a:xfrm>
+            <a:off x="6567196" y="3956179"/>
+            <a:ext cx="381000" cy="228600"/>
+          </a:xfrm>
+          <a:prstGeom prst="rect">
+            <a:avLst/>
+          </a:prstGeom>
+          <a:noFill/>
+          <a:ln w="38100">
+            <a:solidFill>
+              <a:srgbClr val="FF0000"/>
+            </a:solidFill>
+          </a:ln>
+        </p:spPr>
+        <p:style>
+          <a:lnRef idx="2">
+            <a:schemeClr val="accent6"/>
+          </a:lnRef>
+          <a:fillRef idx="1">
+            <a:schemeClr val="lt1"/>
+          </a:fillRef>
+          <a:effectRef idx="0">
+            <a:schemeClr val="accent6"/>
+          </a:effectRef>
+          <a:fontRef idx="minor">
+            <a:schemeClr val="dk1"/>
+          </a:fontRef>
+        </p:style>
+        <p:txBody>
+          <a:bodyPr rtlCol="0" anchor="ctr"/>
+          <a:lstStyle/>
+          <a:p>
+            <a:pPr algn="ctr"/>
+            <a:endParaRPr lang="en-IN"/>
+          </a:p>
+        </p:txBody>
+      </p:sp>
+      <p:sp>
+        <p:nvSpPr>
+          <p:cNvPr id="15" name="Rectangle 14">
+            <a:extLst>
+              <a:ext uri="{FF2B5EF4-FFF2-40B4-BE49-F238E27FC236}">
+                <a16:creationId xmlns:a16="http://schemas.microsoft.com/office/drawing/2014/main" id="{BCCC1445-8308-0C4B-B11E-B639404B59F7}"/>
+              </a:ext>
+            </a:extLst>
+          </p:cNvPr>
+          <p:cNvSpPr/>
+          <p:nvPr/>
+        </p:nvSpPr>
+        <p:spPr>
+          <a:xfrm>
+            <a:off x="6941477" y="4371591"/>
+            <a:ext cx="381000" cy="228600"/>
+          </a:xfrm>
+          <a:prstGeom prst="rect">
+            <a:avLst/>
+          </a:prstGeom>
+          <a:noFill/>
+          <a:ln w="38100">
+            <a:solidFill>
+              <a:srgbClr val="FF0000"/>
+            </a:solidFill>
+          </a:ln>
+        </p:spPr>
+        <p:style>
+          <a:lnRef idx="2">
+            <a:schemeClr val="accent6"/>
+          </a:lnRef>
+          <a:fillRef idx="1">
+            <a:schemeClr val="lt1"/>
+          </a:fillRef>
+          <a:effectRef idx="0">
+            <a:schemeClr val="accent6"/>
+          </a:effectRef>
+          <a:fontRef idx="minor">
+            <a:schemeClr val="dk1"/>
+          </a:fontRef>
+        </p:style>
+        <p:txBody>
+          <a:bodyPr rtlCol="0" anchor="ctr"/>
+          <a:lstStyle/>
+          <a:p>
+            <a:pPr algn="ctr"/>
+            <a:endParaRPr lang="en-IN"/>
+          </a:p>
+        </p:txBody>
+      </p:sp>
+      <p:sp>
+        <p:nvSpPr>
+          <p:cNvPr id="16" name="Rectangle 15">
+            <a:extLst>
+              <a:ext uri="{FF2B5EF4-FFF2-40B4-BE49-F238E27FC236}">
+                <a16:creationId xmlns:a16="http://schemas.microsoft.com/office/drawing/2014/main" id="{7FF4D821-DB5E-ACDD-4D2A-D910480983A6}"/>
+              </a:ext>
+            </a:extLst>
+          </p:cNvPr>
+          <p:cNvSpPr/>
+          <p:nvPr/>
+        </p:nvSpPr>
+        <p:spPr>
+          <a:xfrm>
+            <a:off x="6941477" y="4377774"/>
+            <a:ext cx="381000" cy="222218"/>
+          </a:xfrm>
+          <a:prstGeom prst="rect">
+            <a:avLst/>
+          </a:prstGeom>
+          <a:noFill/>
+          <a:ln w="38100">
+            <a:solidFill>
+              <a:srgbClr val="00FF00"/>
+            </a:solidFill>
+          </a:ln>
+        </p:spPr>
+        <p:style>
+          <a:lnRef idx="2">
+            <a:schemeClr val="accent6"/>
+          </a:lnRef>
+          <a:fillRef idx="1">
+            <a:schemeClr val="lt1"/>
+          </a:fillRef>
+          <a:effectRef idx="0">
+            <a:schemeClr val="accent6"/>
+          </a:effectRef>
+          <a:fontRef idx="minor">
+            <a:schemeClr val="dk1"/>
+          </a:fontRef>
+        </p:style>
+        <p:txBody>
+          <a:bodyPr rtlCol="0" anchor="ctr"/>
+          <a:lstStyle/>
+          <a:p>
+            <a:pPr algn="ctr"/>
+            <a:endParaRPr lang="en-IN"/>
+          </a:p>
+        </p:txBody>
+      </p:sp>
+    </p:spTree>
+    <p:extLst>
+      <p:ext uri="{BB962C8B-B14F-4D97-AF65-F5344CB8AC3E}">
+        <p14:creationId xmlns:p14="http://schemas.microsoft.com/office/powerpoint/2010/main" val="766500991"/>
+      </p:ext>
+    </p:extLst>
+  </p:cSld>
+  <p:clrMapOvr>
+    <a:masterClrMapping/>
+  </p:clrMapOvr>
+  <p:timing>
+    <p:tnLst>
+      <p:par>
+        <p:cTn id="1" dur="indefinite" restart="never" nodeType="tmRoot">
+          <p:childTnLst>
+            <p:seq concurrent="1" nextAc="seek">
+              <p:cTn id="2" dur="indefinite" nodeType="mainSeq">
+                <p:childTnLst>
+                  <p:par>
+                    <p:cTn id="3" fill="hold">
+                      <p:stCondLst>
+                        <p:cond delay="indefinite"/>
+                      </p:stCondLst>
+                      <p:childTnLst>
+                        <p:par>
+                          <p:cTn id="4" fill="hold">
+                            <p:stCondLst>
+                              <p:cond delay="0"/>
+                            </p:stCondLst>
+                            <p:childTnLst>
+                              <p:par>
+                                <p:cTn id="5" presetID="1" presetClass="entr" presetSubtype="0" fill="hold" grpId="0" nodeType="clickEffect">
+                                  <p:stCondLst>
+                                    <p:cond delay="0"/>
+                                  </p:stCondLst>
+                                  <p:childTnLst>
+                                    <p:set>
+                                      <p:cBhvr>
+                                        <p:cTn id="6" dur="1" fill="hold">
+                                          <p:stCondLst>
+                                            <p:cond delay="0"/>
+                                          </p:stCondLst>
+                                        </p:cTn>
+                                        <p:tgtEl>
+                                          <p:spTgt spid="12">
+                                            <p:txEl>
+                                              <p:pRg st="0" end="0"/>
+                                            </p:txEl>
+                                          </p:spTgt>
+                                        </p:tgtEl>
+                                        <p:attrNameLst>
+                                          <p:attrName>style.visibility</p:attrName>
+                                        </p:attrNameLst>
+                                      </p:cBhvr>
+                                      <p:to>
+                                        <p:strVal val="visible"/>
+                                      </p:to>
+                                    </p:set>
+                                  </p:childTnLst>
+                                </p:cTn>
+                              </p:par>
+                            </p:childTnLst>
+                          </p:cTn>
+                        </p:par>
+                      </p:childTnLst>
+                    </p:cTn>
+                  </p:par>
+                  <p:par>
+                    <p:cTn id="7" fill="hold">
+                      <p:stCondLst>
+                        <p:cond delay="indefinite"/>
+                      </p:stCondLst>
+                      <p:childTnLst>
+                        <p:par>
+                          <p:cTn id="8" fill="hold">
+                            <p:stCondLst>
+                              <p:cond delay="0"/>
+                            </p:stCondLst>
+                            <p:childTnLst>
+                              <p:par>
+                                <p:cTn id="9" presetID="1" presetClass="entr" presetSubtype="0" fill="hold" grpId="0" nodeType="clickEffect">
+                                  <p:stCondLst>
+                                    <p:cond delay="0"/>
+                                  </p:stCondLst>
+                                  <p:childTnLst>
+                                    <p:set>
+                                      <p:cBhvr>
+                                        <p:cTn id="10" dur="1" fill="hold">
+                                          <p:stCondLst>
+                                            <p:cond delay="0"/>
+                                          </p:stCondLst>
+                                        </p:cTn>
+                                        <p:tgtEl>
+                                          <p:spTgt spid="12">
+                                            <p:txEl>
+                                              <p:pRg st="1" end="1"/>
+                                            </p:txEl>
+                                          </p:spTgt>
+                                        </p:tgtEl>
+                                        <p:attrNameLst>
+                                          <p:attrName>style.visibility</p:attrName>
+                                        </p:attrNameLst>
+                                      </p:cBhvr>
+                                      <p:to>
+                                        <p:strVal val="visible"/>
+                                      </p:to>
+                                    </p:set>
+                                  </p:childTnLst>
+                                </p:cTn>
+                              </p:par>
+                            </p:childTnLst>
+                          </p:cTn>
+                        </p:par>
+                      </p:childTnLst>
+                    </p:cTn>
+                  </p:par>
+                  <p:par>
+                    <p:cTn id="11" fill="hold">
+                      <p:stCondLst>
+                        <p:cond delay="indefinite"/>
+                      </p:stCondLst>
+                      <p:childTnLst>
+                        <p:par>
+                          <p:cTn id="12" fill="hold">
+                            <p:stCondLst>
+                              <p:cond delay="0"/>
+                            </p:stCondLst>
+                            <p:childTnLst>
+                              <p:par>
+                                <p:cTn id="13" presetID="1" presetClass="entr" presetSubtype="0" fill="hold" grpId="0" nodeType="clickEffect">
+                                  <p:stCondLst>
+                                    <p:cond delay="0"/>
+                                  </p:stCondLst>
+                                  <p:childTnLst>
+                                    <p:set>
+                                      <p:cBhvr>
+                                        <p:cTn id="14" dur="1" fill="hold">
+                                          <p:stCondLst>
+                                            <p:cond delay="0"/>
+                                          </p:stCondLst>
+                                        </p:cTn>
+                                        <p:tgtEl>
+                                          <p:spTgt spid="12">
+                                            <p:txEl>
+                                              <p:pRg st="2" end="2"/>
+                                            </p:txEl>
+                                          </p:spTgt>
+                                        </p:tgtEl>
+                                        <p:attrNameLst>
+                                          <p:attrName>style.visibility</p:attrName>
+                                        </p:attrNameLst>
+                                      </p:cBhvr>
+                                      <p:to>
+                                        <p:strVal val="visible"/>
+                                      </p:to>
+                                    </p:set>
+                                  </p:childTnLst>
+                                </p:cTn>
+                              </p:par>
+                            </p:childTnLst>
+                          </p:cTn>
+                        </p:par>
+                      </p:childTnLst>
+                    </p:cTn>
+                  </p:par>
+                  <p:par>
+                    <p:cTn id="15" fill="hold">
+                      <p:stCondLst>
+                        <p:cond delay="indefinite"/>
+                      </p:stCondLst>
+                      <p:childTnLst>
+                        <p:par>
+                          <p:cTn id="16" fill="hold">
+                            <p:stCondLst>
+                              <p:cond delay="0"/>
+                            </p:stCondLst>
+                            <p:childTnLst>
+                              <p:par>
+                                <p:cTn id="17" presetID="1" presetClass="entr" presetSubtype="0" fill="hold" nodeType="clickEffect">
+                                  <p:stCondLst>
+                                    <p:cond delay="0"/>
+                                  </p:stCondLst>
+                                  <p:childTnLst>
+                                    <p:set>
+                                      <p:cBhvr>
+                                        <p:cTn id="18" dur="1" fill="hold">
+                                          <p:stCondLst>
+                                            <p:cond delay="0"/>
+                                          </p:stCondLst>
+                                        </p:cTn>
+                                        <p:tgtEl>
+                                          <p:spTgt spid="10"/>
+                                        </p:tgtEl>
+                                        <p:attrNameLst>
+                                          <p:attrName>style.visibility</p:attrName>
+                                        </p:attrNameLst>
+                                      </p:cBhvr>
+                                      <p:to>
+                                        <p:strVal val="visible"/>
+                                      </p:to>
+                                    </p:set>
+                                  </p:childTnLst>
+                                </p:cTn>
+                              </p:par>
+                            </p:childTnLst>
+                          </p:cTn>
+                        </p:par>
+                      </p:childTnLst>
+                    </p:cTn>
+                  </p:par>
+                  <p:par>
+                    <p:cTn id="19" fill="hold">
+                      <p:stCondLst>
+                        <p:cond delay="indefinite"/>
+                      </p:stCondLst>
+                      <p:childTnLst>
+                        <p:par>
+                          <p:cTn id="20" fill="hold">
+                            <p:stCondLst>
+                              <p:cond delay="0"/>
+                            </p:stCondLst>
+                            <p:childTnLst>
+                              <p:par>
+                                <p:cTn id="21" presetID="1" presetClass="entr" presetSubtype="0" fill="hold" nodeType="clickEffect">
+                                  <p:stCondLst>
+                                    <p:cond delay="0"/>
+                                  </p:stCondLst>
+                                  <p:childTnLst>
+                                    <p:set>
+                                      <p:cBhvr>
+                                        <p:cTn id="22" dur="1" fill="hold">
+                                          <p:stCondLst>
+                                            <p:cond delay="0"/>
+                                          </p:stCondLst>
+                                        </p:cTn>
+                                        <p:tgtEl>
+                                          <p:spTgt spid="11"/>
+                                        </p:tgtEl>
+                                        <p:attrNameLst>
+                                          <p:attrName>style.visibility</p:attrName>
+                                        </p:attrNameLst>
+                                      </p:cBhvr>
+                                      <p:to>
+                                        <p:strVal val="visible"/>
+                                      </p:to>
+                                    </p:set>
+                                  </p:childTnLst>
+                                </p:cTn>
+                              </p:par>
+                            </p:childTnLst>
+                          </p:cTn>
+                        </p:par>
+                      </p:childTnLst>
+                    </p:cTn>
+                  </p:par>
+                  <p:par>
+                    <p:cTn id="23" fill="hold">
+                      <p:stCondLst>
+                        <p:cond delay="indefinite"/>
+                      </p:stCondLst>
+                      <p:childTnLst>
+                        <p:par>
+                          <p:cTn id="24" fill="hold">
+                            <p:stCondLst>
+                              <p:cond delay="0"/>
+                            </p:stCondLst>
+                            <p:childTnLst>
+                              <p:par>
+                                <p:cTn id="25" presetID="1" presetClass="entr" presetSubtype="0" fill="hold" grpId="0" nodeType="clickEffect">
+                                  <p:stCondLst>
+                                    <p:cond delay="0"/>
+                                  </p:stCondLst>
+                                  <p:childTnLst>
+                                    <p:set>
+                                      <p:cBhvr>
+                                        <p:cTn id="26" dur="1" fill="hold">
+                                          <p:stCondLst>
+                                            <p:cond delay="0"/>
+                                          </p:stCondLst>
+                                        </p:cTn>
+                                        <p:tgtEl>
+                                          <p:spTgt spid="13"/>
+                                        </p:tgtEl>
+                                        <p:attrNameLst>
+                                          <p:attrName>style.visibility</p:attrName>
+                                        </p:attrNameLst>
+                                      </p:cBhvr>
+                                      <p:to>
+                                        <p:strVal val="visible"/>
+                                      </p:to>
+                                    </p:set>
+                                  </p:childTnLst>
+                                </p:cTn>
+                              </p:par>
+                            </p:childTnLst>
+                          </p:cTn>
+                        </p:par>
+                      </p:childTnLst>
+                    </p:cTn>
+                  </p:par>
+                  <p:par>
+                    <p:cTn id="27" fill="hold">
+                      <p:stCondLst>
+                        <p:cond delay="indefinite"/>
+                      </p:stCondLst>
+                      <p:childTnLst>
+                        <p:par>
+                          <p:cTn id="28" fill="hold">
+                            <p:stCondLst>
+                              <p:cond delay="0"/>
+                            </p:stCondLst>
+                            <p:childTnLst>
+                              <p:par>
+                                <p:cTn id="29" presetID="1" presetClass="entr" presetSubtype="0" fill="hold" grpId="0" nodeType="clickEffect">
+                                  <p:stCondLst>
+                                    <p:cond delay="0"/>
+                                  </p:stCondLst>
+                                  <p:childTnLst>
+                                    <p:set>
+                                      <p:cBhvr>
+                                        <p:cTn id="30" dur="1" fill="hold">
+                                          <p:stCondLst>
+                                            <p:cond delay="0"/>
+                                          </p:stCondLst>
+                                        </p:cTn>
+                                        <p:tgtEl>
+                                          <p:spTgt spid="14"/>
+                                        </p:tgtEl>
+                                        <p:attrNameLst>
+                                          <p:attrName>style.visibility</p:attrName>
+                                        </p:attrNameLst>
+                                      </p:cBhvr>
+                                      <p:to>
+                                        <p:strVal val="visible"/>
+                                      </p:to>
+                                    </p:set>
+                                  </p:childTnLst>
+                                </p:cTn>
+                              </p:par>
+                            </p:childTnLst>
+                          </p:cTn>
+                        </p:par>
+                      </p:childTnLst>
+                    </p:cTn>
+                  </p:par>
+                  <p:par>
+                    <p:cTn id="31" fill="hold">
+                      <p:stCondLst>
+                        <p:cond delay="indefinite"/>
+                      </p:stCondLst>
+                      <p:childTnLst>
+                        <p:par>
+                          <p:cTn id="32" fill="hold">
+                            <p:stCondLst>
+                              <p:cond delay="0"/>
+                            </p:stCondLst>
+                            <p:childTnLst>
+                              <p:par>
+                                <p:cTn id="33" presetID="1" presetClass="entr" presetSubtype="0" fill="hold" grpId="0" nodeType="clickEffect">
+                                  <p:stCondLst>
+                                    <p:cond delay="0"/>
+                                  </p:stCondLst>
+                                  <p:childTnLst>
+                                    <p:set>
+                                      <p:cBhvr>
+                                        <p:cTn id="34" dur="1" fill="hold">
+                                          <p:stCondLst>
+                                            <p:cond delay="0"/>
+                                          </p:stCondLst>
+                                        </p:cTn>
+                                        <p:tgtEl>
+                                          <p:spTgt spid="15"/>
+                                        </p:tgtEl>
+                                        <p:attrNameLst>
+                                          <p:attrName>style.visibility</p:attrName>
+                                        </p:attrNameLst>
+                                      </p:cBhvr>
+                                      <p:to>
+                                        <p:strVal val="visible"/>
+                                      </p:to>
+                                    </p:set>
+                                  </p:childTnLst>
+                                </p:cTn>
+                              </p:par>
+                            </p:childTnLst>
+                          </p:cTn>
+                        </p:par>
+                      </p:childTnLst>
+                    </p:cTn>
+                  </p:par>
+                  <p:par>
+                    <p:cTn id="35" fill="hold">
+                      <p:stCondLst>
+                        <p:cond delay="indefinite"/>
+                      </p:stCondLst>
+                      <p:childTnLst>
+                        <p:par>
+                          <p:cTn id="36" fill="hold">
+                            <p:stCondLst>
+                              <p:cond delay="0"/>
+                            </p:stCondLst>
+                            <p:childTnLst>
+                              <p:par>
+                                <p:cTn id="37" presetID="1" presetClass="entr" presetSubtype="0" fill="hold" grpId="0" nodeType="clickEffect">
+                                  <p:stCondLst>
+                                    <p:cond delay="0"/>
+                                  </p:stCondLst>
+                                  <p:childTnLst>
+                                    <p:set>
+                                      <p:cBhvr>
+                                        <p:cTn id="38" dur="1" fill="hold">
+                                          <p:stCondLst>
+                                            <p:cond delay="0"/>
+                                          </p:stCondLst>
+                                        </p:cTn>
+                                        <p:tgtEl>
+                                          <p:spTgt spid="16"/>
+                                        </p:tgtEl>
+                                        <p:attrNameLst>
+                                          <p:attrName>style.visibility</p:attrName>
+                                        </p:attrNameLst>
+                                      </p:cBhvr>
+                                      <p:to>
+                                        <p:strVal val="visible"/>
+                                      </p:to>
+                                    </p:set>
+                                  </p:childTnLst>
+                                </p:cTn>
+                              </p:par>
+                            </p:childTnLst>
+                          </p:cTn>
+                        </p:par>
+                      </p:childTnLst>
+                    </p:cTn>
+                  </p:par>
+                </p:childTnLst>
+              </p:cTn>
+              <p:prevCondLst>
+                <p:cond evt="onPrev" delay="0">
+                  <p:tgtEl>
+                    <p:sldTgt/>
+                  </p:tgtEl>
+                </p:cond>
+              </p:prevCondLst>
+              <p:nextCondLst>
+                <p:cond evt="onNext" delay="0">
+                  <p:tgtEl>
+                    <p:sldTgt/>
+                  </p:tgtEl>
+                </p:cond>
+              </p:nextCondLst>
+            </p:seq>
+          </p:childTnLst>
+        </p:cTn>
+      </p:par>
+    </p:tnLst>
+    <p:bldLst>
+      <p:bldP spid="12" grpId="0" build="p"/>
+      <p:bldP spid="13" grpId="0" animBg="1"/>
+      <p:bldP spid="14" grpId="0" animBg="1"/>
+      <p:bldP spid="15" grpId="0" animBg="1"/>
+      <p:bldP spid="16" grpId="0" animBg="1"/>
+    </p:bldLst>
+  </p:timing>
+</p:sld>
+</file>
+
+<file path=ppt/slides/slide17.xml><?xml version="1.0" encoding="utf-8"?>
+<p:sld xmlns:a="http://schemas.openxmlformats.org/drawingml/2006/main" xmlns:r="http://schemas.openxmlformats.org/officeDocument/2006/relationships" xmlns:p="http://schemas.openxmlformats.org/presentationml/2006/main">
+  <p:cSld>
+    <p:spTree>
+      <p:nvGrpSpPr>
+        <p:cNvPr id="1" name=""/>
+        <p:cNvGrpSpPr/>
+        <p:nvPr/>
+      </p:nvGrpSpPr>
+      <p:grpSpPr>
+        <a:xfrm>
+          <a:off x="0" y="0"/>
+          <a:ext cx="0" cy="0"/>
+          <a:chOff x="0" y="0"/>
+          <a:chExt cx="0" cy="0"/>
+        </a:xfrm>
+      </p:grpSpPr>
+      <p:sp>
+        <p:nvSpPr>
+          <p:cNvPr id="2" name="Title 1">
+            <a:extLst>
+              <a:ext uri="{FF2B5EF4-FFF2-40B4-BE49-F238E27FC236}">
+                <a16:creationId xmlns:a16="http://schemas.microsoft.com/office/drawing/2014/main" id="{DC5B9578-289F-7361-6E7C-6F93AA70B0BC}"/>
+              </a:ext>
+            </a:extLst>
+          </p:cNvPr>
+          <p:cNvSpPr>
+            <a:spLocks noGrp="1"/>
+          </p:cNvSpPr>
+          <p:nvPr>
+            <p:ph type="title"/>
+          </p:nvPr>
+        </p:nvSpPr>
+        <p:spPr/>
+        <p:txBody>
+          <a:bodyPr/>
+          <a:lstStyle/>
+          <a:p>
+            <a:r>
+              <a:rPr lang="en-US" dirty="0"/>
+              <a:t>Data hazard solution – bubbles (stalling)</a:t>
+            </a:r>
+          </a:p>
+        </p:txBody>
+      </p:sp>
+      <p:pic>
+        <p:nvPicPr>
+          <p:cNvPr id="8" name="Content Placeholder 7">
+            <a:extLst>
+              <a:ext uri="{FF2B5EF4-FFF2-40B4-BE49-F238E27FC236}">
+                <a16:creationId xmlns:a16="http://schemas.microsoft.com/office/drawing/2014/main" id="{436127FF-0284-EEB4-CBBA-9F89ADA4BAAB}"/>
+              </a:ext>
+            </a:extLst>
+          </p:cNvPr>
+          <p:cNvPicPr>
+            <a:picLocks noGrp="1" noChangeAspect="1"/>
+          </p:cNvPicPr>
+          <p:nvPr>
+            <p:ph idx="1"/>
+          </p:nvPr>
+        </p:nvPicPr>
+        <p:blipFill>
+          <a:blip r:embed="rId2"/>
+          <a:stretch>
+            <a:fillRect/>
+          </a:stretch>
+        </p:blipFill>
+        <p:spPr>
+          <a:xfrm>
+            <a:off x="2231905" y="1552855"/>
+            <a:ext cx="6867998" cy="2352487"/>
+          </a:xfrm>
+        </p:spPr>
+      </p:pic>
+      <p:sp>
+        <p:nvSpPr>
+          <p:cNvPr id="4" name="Date Placeholder 3">
+            <a:extLst>
+              <a:ext uri="{FF2B5EF4-FFF2-40B4-BE49-F238E27FC236}">
+                <a16:creationId xmlns:a16="http://schemas.microsoft.com/office/drawing/2014/main" id="{C9E8E2A0-3D68-944C-2F37-6CA64E76A39F}"/>
+              </a:ext>
+            </a:extLst>
+          </p:cNvPr>
+          <p:cNvSpPr>
+            <a:spLocks noGrp="1"/>
+          </p:cNvSpPr>
+          <p:nvPr>
+            <p:ph type="dt" sz="half" idx="10"/>
+          </p:nvPr>
+        </p:nvSpPr>
+        <p:spPr/>
+        <p:txBody>
+          <a:bodyPr/>
+          <a:lstStyle/>
+          <a:p>
+            <a:fld id="{B4B13859-67C5-4393-B6C2-556CF3F770C0}" type="datetime3">
+              <a:rPr lang="en-US" smtClean="0"/>
+              <a:t>23 February 2026</a:t>
+            </a:fld>
+            <a:endParaRPr lang="en-US"/>
+          </a:p>
+        </p:txBody>
+      </p:sp>
+      <p:sp>
+        <p:nvSpPr>
+          <p:cNvPr id="6" name="Slide Number Placeholder 5">
+            <a:extLst>
+              <a:ext uri="{FF2B5EF4-FFF2-40B4-BE49-F238E27FC236}">
+                <a16:creationId xmlns:a16="http://schemas.microsoft.com/office/drawing/2014/main" id="{70146E4A-4437-AB75-1669-331861CFDDC9}"/>
+              </a:ext>
+            </a:extLst>
+          </p:cNvPr>
+          <p:cNvSpPr>
+            <a:spLocks noGrp="1"/>
+          </p:cNvSpPr>
+          <p:nvPr>
+            <p:ph type="sldNum" sz="quarter" idx="12"/>
+          </p:nvPr>
+        </p:nvSpPr>
+        <p:spPr/>
+        <p:txBody>
+          <a:bodyPr/>
+          <a:lstStyle/>
+          <a:p>
+            <a:fld id="{98AC3541-01C1-4CA5-B68F-FEE868C7D1AF}" type="slidenum">
+              <a:rPr lang="en-US" smtClean="0"/>
+              <a:t>17</a:t>
+            </a:fld>
+            <a:endParaRPr lang="en-US"/>
+          </a:p>
+        </p:txBody>
+      </p:sp>
+      <p:sp>
+        <p:nvSpPr>
+          <p:cNvPr id="10" name="TextBox 9">
+            <a:extLst>
+              <a:ext uri="{FF2B5EF4-FFF2-40B4-BE49-F238E27FC236}">
+                <a16:creationId xmlns:a16="http://schemas.microsoft.com/office/drawing/2014/main" id="{0F5C724A-47E6-F89F-984C-8DA468AFA23F}"/>
+              </a:ext>
+            </a:extLst>
+          </p:cNvPr>
+          <p:cNvSpPr txBox="1"/>
+          <p:nvPr/>
+        </p:nvSpPr>
+        <p:spPr>
+          <a:xfrm>
+            <a:off x="17106" y="2277853"/>
+            <a:ext cx="3259494" cy="1200329"/>
+          </a:xfrm>
+          <a:prstGeom prst="rect">
+            <a:avLst/>
+          </a:prstGeom>
+          <a:noFill/>
+        </p:spPr>
+        <p:txBody>
+          <a:bodyPr wrap="square">
+            <a:spAutoFit/>
+          </a:bodyPr>
+          <a:lstStyle/>
+          <a:p>
+            <a:r>
+              <a:rPr lang="en-US" dirty="0"/>
+              <a:t>Bubbles: affected pipeline stages do “nothing” for a  cycle.</a:t>
+            </a:r>
+          </a:p>
+          <a:p>
+            <a:r>
+              <a:rPr lang="en-US" dirty="0">
+                <a:solidFill>
+                  <a:srgbClr val="FF0000"/>
+                </a:solidFill>
+              </a:rPr>
+              <a:t>How many bubbles in RAW?</a:t>
+            </a:r>
+          </a:p>
+        </p:txBody>
+      </p:sp>
+      <p:sp>
+        <p:nvSpPr>
+          <p:cNvPr id="12" name="TextBox 11">
+            <a:extLst>
+              <a:ext uri="{FF2B5EF4-FFF2-40B4-BE49-F238E27FC236}">
+                <a16:creationId xmlns:a16="http://schemas.microsoft.com/office/drawing/2014/main" id="{B2BF490F-9CAB-7E2C-F585-4AF69BD0B502}"/>
+              </a:ext>
+            </a:extLst>
+          </p:cNvPr>
+          <p:cNvSpPr txBox="1"/>
+          <p:nvPr/>
+        </p:nvSpPr>
+        <p:spPr>
+          <a:xfrm>
+            <a:off x="172942" y="4149202"/>
+            <a:ext cx="5161058" cy="2308324"/>
+          </a:xfrm>
+          <a:prstGeom prst="rect">
+            <a:avLst/>
+          </a:prstGeom>
+          <a:noFill/>
+        </p:spPr>
+        <p:txBody>
+          <a:bodyPr wrap="square">
+            <a:spAutoFit/>
+          </a:bodyPr>
+          <a:lstStyle/>
+          <a:p>
+            <a:pPr marL="214313" indent="-214313">
+              <a:buFont typeface="Arial" panose="020B0604020202020204" pitchFamily="34" charset="0"/>
+              <a:buChar char="•"/>
+            </a:pPr>
+            <a:r>
+              <a:rPr lang="en-US" dirty="0"/>
+              <a:t>Stalls reduce performance</a:t>
+            </a:r>
+          </a:p>
+          <a:p>
+            <a:pPr marL="214313" indent="-214313">
+              <a:buFont typeface="Arial" panose="020B0604020202020204" pitchFamily="34" charset="0"/>
+              <a:buChar char="•"/>
+            </a:pPr>
+            <a:endParaRPr lang="en-US" dirty="0"/>
+          </a:p>
+          <a:p>
+            <a:pPr marL="214313" indent="-214313">
+              <a:buFont typeface="Arial" panose="020B0604020202020204" pitchFamily="34" charset="0"/>
+              <a:buChar char="•"/>
+            </a:pPr>
+            <a:r>
+              <a:rPr lang="en-US" dirty="0">
+                <a:solidFill>
+                  <a:srgbClr val="FF0000"/>
+                </a:solidFill>
+              </a:rPr>
+              <a:t>How to mitigate stall performance degradation?</a:t>
+            </a:r>
+          </a:p>
+          <a:p>
+            <a:pPr marL="214313" indent="-214313">
+              <a:buFont typeface="Arial" panose="020B0604020202020204" pitchFamily="34" charset="0"/>
+              <a:buChar char="•"/>
+            </a:pPr>
+            <a:r>
+              <a:rPr lang="en-US" dirty="0"/>
+              <a:t>Compilers can arrange the instructions such that these conditions are avoided</a:t>
+            </a:r>
+          </a:p>
+          <a:p>
+            <a:pPr marL="557213" lvl="1" indent="-214313">
+              <a:buFont typeface="Arial" panose="020B0604020202020204" pitchFamily="34" charset="0"/>
+              <a:buChar char="•"/>
+            </a:pPr>
+            <a:r>
+              <a:rPr lang="en-US" dirty="0"/>
+              <a:t>Compilers must know how the pipeline is implemented and how instructions interact</a:t>
+            </a:r>
+          </a:p>
+        </p:txBody>
+      </p:sp>
+      <p:pic>
+        <p:nvPicPr>
+          <p:cNvPr id="7" name="Picture 6">
+            <a:extLst>
+              <a:ext uri="{FF2B5EF4-FFF2-40B4-BE49-F238E27FC236}">
+                <a16:creationId xmlns:a16="http://schemas.microsoft.com/office/drawing/2014/main" id="{76DEE025-B5C6-7CF5-62F1-FA3D6C1E9A6C}"/>
+              </a:ext>
+            </a:extLst>
+          </p:cNvPr>
+          <p:cNvPicPr>
+            <a:picLocks noChangeAspect="1"/>
+          </p:cNvPicPr>
+          <p:nvPr/>
+        </p:nvPicPr>
+        <p:blipFill>
+          <a:blip r:embed="rId3"/>
+          <a:stretch>
+            <a:fillRect/>
+          </a:stretch>
+        </p:blipFill>
+        <p:spPr>
+          <a:xfrm>
+            <a:off x="5257800" y="4343400"/>
+            <a:ext cx="1676400" cy="838200"/>
+          </a:xfrm>
+          <a:prstGeom prst="rect">
+            <a:avLst/>
+          </a:prstGeom>
+        </p:spPr>
+      </p:pic>
+      <p:grpSp>
+        <p:nvGrpSpPr>
+          <p:cNvPr id="16" name="Group 15">
+            <a:extLst>
+              <a:ext uri="{FF2B5EF4-FFF2-40B4-BE49-F238E27FC236}">
+                <a16:creationId xmlns:a16="http://schemas.microsoft.com/office/drawing/2014/main" id="{0115D45D-2805-75B4-6D1C-66FFE9B6D287}"/>
+              </a:ext>
+            </a:extLst>
+          </p:cNvPr>
+          <p:cNvGrpSpPr/>
+          <p:nvPr/>
+        </p:nvGrpSpPr>
+        <p:grpSpPr>
+          <a:xfrm>
+            <a:off x="6035351" y="5292478"/>
+            <a:ext cx="2446951" cy="1165048"/>
+            <a:chOff x="6035351" y="5292478"/>
+            <a:chExt cx="2446951" cy="1165048"/>
+          </a:xfrm>
+        </p:grpSpPr>
+        <p:pic>
+          <p:nvPicPr>
+            <p:cNvPr id="11" name="Picture 10">
+              <a:extLst>
+                <a:ext uri="{FF2B5EF4-FFF2-40B4-BE49-F238E27FC236}">
+                  <a16:creationId xmlns:a16="http://schemas.microsoft.com/office/drawing/2014/main" id="{D83BBD28-DA05-943E-7586-EAB693AA85E4}"/>
+                </a:ext>
+              </a:extLst>
+            </p:cNvPr>
+            <p:cNvPicPr>
+              <a:picLocks noChangeAspect="1"/>
+            </p:cNvPicPr>
+            <p:nvPr/>
+          </p:nvPicPr>
+          <p:blipFill>
+            <a:blip r:embed="rId4"/>
+            <a:stretch>
+              <a:fillRect/>
+            </a:stretch>
+          </p:blipFill>
+          <p:spPr>
+            <a:xfrm>
+              <a:off x="6629399" y="5309312"/>
+              <a:ext cx="1676399" cy="845127"/>
+            </a:xfrm>
+            <a:prstGeom prst="rect">
+              <a:avLst/>
+            </a:prstGeom>
+          </p:spPr>
+        </p:pic>
+        <p:sp>
+          <p:nvSpPr>
+            <p:cNvPr id="13" name="Arrow: Bent-Up 12">
+              <a:extLst>
+                <a:ext uri="{FF2B5EF4-FFF2-40B4-BE49-F238E27FC236}">
+                  <a16:creationId xmlns:a16="http://schemas.microsoft.com/office/drawing/2014/main" id="{458E9916-23A1-F95F-5BD2-1D4801C652BD}"/>
+                </a:ext>
+              </a:extLst>
+            </p:cNvPr>
+            <p:cNvSpPr/>
+            <p:nvPr/>
+          </p:nvSpPr>
+          <p:spPr>
+            <a:xfrm rot="5400000">
+              <a:off x="5947552" y="5380277"/>
+              <a:ext cx="649562" cy="473964"/>
+            </a:xfrm>
+            <a:prstGeom prst="bentUpArrow">
+              <a:avLst/>
+            </a:prstGeom>
+            <a:solidFill>
+              <a:schemeClr val="dk1">
+                <a:alpha val="50000"/>
+              </a:schemeClr>
+            </a:solidFill>
+            <a:ln>
+              <a:noFill/>
+            </a:ln>
+          </p:spPr>
+          <p:style>
+            <a:lnRef idx="0">
+              <a:scrgbClr r="0" g="0" b="0"/>
+            </a:lnRef>
+            <a:fillRef idx="0">
+              <a:scrgbClr r="0" g="0" b="0"/>
+            </a:fillRef>
+            <a:effectRef idx="0">
+              <a:scrgbClr r="0" g="0" b="0"/>
+            </a:effectRef>
+            <a:fontRef idx="minor">
+              <a:schemeClr val="lt1"/>
+            </a:fontRef>
+          </p:style>
+          <p:txBody>
+            <a:bodyPr rtlCol="0" anchor="ctr"/>
+            <a:lstStyle/>
+            <a:p>
+              <a:pPr algn="ctr"/>
+              <a:endParaRPr lang="en-IN"/>
+            </a:p>
+          </p:txBody>
+        </p:sp>
+        <p:sp>
+          <p:nvSpPr>
+            <p:cNvPr id="15" name="TextBox 14">
+              <a:extLst>
+                <a:ext uri="{FF2B5EF4-FFF2-40B4-BE49-F238E27FC236}">
+                  <a16:creationId xmlns:a16="http://schemas.microsoft.com/office/drawing/2014/main" id="{E96978B8-FBE7-7B59-F1E4-06A5987CA086}"/>
+                </a:ext>
+              </a:extLst>
+            </p:cNvPr>
+            <p:cNvSpPr txBox="1"/>
+            <p:nvPr/>
+          </p:nvSpPr>
+          <p:spPr>
+            <a:xfrm>
+              <a:off x="6452894" y="6088194"/>
+              <a:ext cx="2029408" cy="369332"/>
+            </a:xfrm>
+            <a:prstGeom prst="rect">
+              <a:avLst/>
+            </a:prstGeom>
+            <a:noFill/>
+          </p:spPr>
+          <p:txBody>
+            <a:bodyPr wrap="square">
+              <a:spAutoFit/>
+            </a:bodyPr>
+            <a:lstStyle/>
+            <a:p>
+              <a:r>
+                <a:rPr lang="en-US" dirty="0">
+                  <a:solidFill>
+                    <a:srgbClr val="FF0000"/>
+                  </a:solidFill>
+                </a:rPr>
+                <a:t>Reduced one stall</a:t>
+              </a:r>
+              <a:endParaRPr lang="en-IN" dirty="0"/>
+            </a:p>
+          </p:txBody>
+        </p:sp>
+      </p:grpSp>
+    </p:spTree>
+    <p:extLst>
+      <p:ext uri="{BB962C8B-B14F-4D97-AF65-F5344CB8AC3E}">
+        <p14:creationId xmlns:p14="http://schemas.microsoft.com/office/powerpoint/2010/main" val="409151751"/>
+      </p:ext>
+    </p:extLst>
+  </p:cSld>
+  <p:clrMapOvr>
+    <a:masterClrMapping/>
+  </p:clrMapOvr>
+  <p:timing>
+    <p:tnLst>
+      <p:par>
+        <p:cTn id="1" dur="indefinite" restart="never" nodeType="tmRoot">
+          <p:childTnLst>
+            <p:seq concurrent="1" nextAc="seek">
+              <p:cTn id="2" dur="indefinite" nodeType="mainSeq">
+                <p:childTnLst>
+                  <p:par>
+                    <p:cTn id="3" fill="hold">
+                      <p:stCondLst>
+                        <p:cond delay="indefinite"/>
+                      </p:stCondLst>
+                      <p:childTnLst>
+                        <p:par>
+                          <p:cTn id="4" fill="hold">
+                            <p:stCondLst>
+                              <p:cond delay="0"/>
+                            </p:stCondLst>
+                            <p:childTnLst>
+                              <p:par>
+                                <p:cTn id="5" presetID="1" presetClass="entr" presetSubtype="0" fill="hold" grpId="0" nodeType="clickEffect">
+                                  <p:stCondLst>
+                                    <p:cond delay="0"/>
+                                  </p:stCondLst>
+                                  <p:childTnLst>
+                                    <p:set>
+                                      <p:cBhvr>
+                                        <p:cTn id="6" dur="1" fill="hold">
+                                          <p:stCondLst>
+                                            <p:cond delay="0"/>
+                                          </p:stCondLst>
+                                        </p:cTn>
+                                        <p:tgtEl>
+                                          <p:spTgt spid="10">
+                                            <p:txEl>
+                                              <p:pRg st="0" end="0"/>
+                                            </p:txEl>
+                                          </p:spTgt>
+                                        </p:tgtEl>
+                                        <p:attrNameLst>
+                                          <p:attrName>style.visibility</p:attrName>
+                                        </p:attrNameLst>
+                                      </p:cBhvr>
+                                      <p:to>
+                                        <p:strVal val="visible"/>
+                                      </p:to>
+                                    </p:set>
+                                  </p:childTnLst>
+                                </p:cTn>
+                              </p:par>
+                            </p:childTnLst>
+                          </p:cTn>
+                        </p:par>
+                      </p:childTnLst>
+                    </p:cTn>
+                  </p:par>
+                  <p:par>
+                    <p:cTn id="7" fill="hold">
+                      <p:stCondLst>
+                        <p:cond delay="indefinite"/>
+                      </p:stCondLst>
+                      <p:childTnLst>
+                        <p:par>
+                          <p:cTn id="8" fill="hold">
+                            <p:stCondLst>
+                              <p:cond delay="0"/>
+                            </p:stCondLst>
+                            <p:childTnLst>
+                              <p:par>
+                                <p:cTn id="9" presetID="1" presetClass="entr" presetSubtype="0" fill="hold" grpId="0" nodeType="clickEffect">
+                                  <p:stCondLst>
+                                    <p:cond delay="0"/>
+                                  </p:stCondLst>
+                                  <p:childTnLst>
+                                    <p:set>
+                                      <p:cBhvr>
+                                        <p:cTn id="10" dur="1" fill="hold">
+                                          <p:stCondLst>
+                                            <p:cond delay="0"/>
+                                          </p:stCondLst>
+                                        </p:cTn>
+                                        <p:tgtEl>
+                                          <p:spTgt spid="10">
+                                            <p:txEl>
+                                              <p:pRg st="1" end="1"/>
+                                            </p:txEl>
+                                          </p:spTgt>
+                                        </p:tgtEl>
+                                        <p:attrNameLst>
+                                          <p:attrName>style.visibility</p:attrName>
+                                        </p:attrNameLst>
+                                      </p:cBhvr>
+                                      <p:to>
+                                        <p:strVal val="visible"/>
+                                      </p:to>
+                                    </p:set>
+                                  </p:childTnLst>
+                                </p:cTn>
+                              </p:par>
+                            </p:childTnLst>
+                          </p:cTn>
+                        </p:par>
+                      </p:childTnLst>
+                    </p:cTn>
+                  </p:par>
+                  <p:par>
+                    <p:cTn id="11" fill="hold">
+                      <p:stCondLst>
+                        <p:cond delay="indefinite"/>
+                      </p:stCondLst>
+                      <p:childTnLst>
+                        <p:par>
+                          <p:cTn id="12" fill="hold">
+                            <p:stCondLst>
+                              <p:cond delay="0"/>
+                            </p:stCondLst>
+                            <p:childTnLst>
+                              <p:par>
+                                <p:cTn id="13" presetID="1" presetClass="entr" presetSubtype="0" fill="hold" nodeType="clickEffect">
+                                  <p:stCondLst>
+                                    <p:cond delay="0"/>
+                                  </p:stCondLst>
+                                  <p:childTnLst>
+                                    <p:set>
+                                      <p:cBhvr>
+                                        <p:cTn id="14" dur="1" fill="hold">
+                                          <p:stCondLst>
+                                            <p:cond delay="0"/>
+                                          </p:stCondLst>
+                                        </p:cTn>
+                                        <p:tgtEl>
+                                          <p:spTgt spid="8"/>
+                                        </p:tgtEl>
+                                        <p:attrNameLst>
+                                          <p:attrName>style.visibility</p:attrName>
+                                        </p:attrNameLst>
+                                      </p:cBhvr>
+                                      <p:to>
+                                        <p:strVal val="visible"/>
+                                      </p:to>
+                                    </p:set>
+                                  </p:childTnLst>
+                                </p:cTn>
+                              </p:par>
+                            </p:childTnLst>
+                          </p:cTn>
+                        </p:par>
+                      </p:childTnLst>
+                    </p:cTn>
+                  </p:par>
+                  <p:par>
+                    <p:cTn id="15" fill="hold">
+                      <p:stCondLst>
+                        <p:cond delay="indefinite"/>
+                      </p:stCondLst>
+                      <p:childTnLst>
+                        <p:par>
+                          <p:cTn id="16" fill="hold">
+                            <p:stCondLst>
+                              <p:cond delay="0"/>
+                            </p:stCondLst>
+                            <p:childTnLst>
+                              <p:par>
+                                <p:cTn id="17" presetID="1" presetClass="entr" presetSubtype="0" fill="hold" grpId="0" nodeType="clickEffect">
+                                  <p:stCondLst>
+                                    <p:cond delay="0"/>
+                                  </p:stCondLst>
+                                  <p:childTnLst>
+                                    <p:set>
+                                      <p:cBhvr>
+                                        <p:cTn id="18" dur="1" fill="hold">
+                                          <p:stCondLst>
+                                            <p:cond delay="0"/>
+                                          </p:stCondLst>
+                                        </p:cTn>
+                                        <p:tgtEl>
+                                          <p:spTgt spid="12">
+                                            <p:txEl>
+                                              <p:pRg st="0" end="0"/>
+                                            </p:txEl>
+                                          </p:spTgt>
+                                        </p:tgtEl>
+                                        <p:attrNameLst>
+                                          <p:attrName>style.visibility</p:attrName>
+                                        </p:attrNameLst>
+                                      </p:cBhvr>
+                                      <p:to>
+                                        <p:strVal val="visible"/>
+                                      </p:to>
+                                    </p:set>
+                                  </p:childTnLst>
+                                </p:cTn>
+                              </p:par>
+                            </p:childTnLst>
+                          </p:cTn>
+                        </p:par>
+                      </p:childTnLst>
+                    </p:cTn>
+                  </p:par>
+                  <p:par>
+                    <p:cTn id="19" fill="hold">
+                      <p:stCondLst>
+                        <p:cond delay="indefinite"/>
+                      </p:stCondLst>
+                      <p:childTnLst>
+                        <p:par>
+                          <p:cTn id="20" fill="hold">
+                            <p:stCondLst>
+                              <p:cond delay="0"/>
+                            </p:stCondLst>
+                            <p:childTnLst>
+                              <p:par>
+                                <p:cTn id="21" presetID="1" presetClass="entr" presetSubtype="0" fill="hold" grpId="0" nodeType="clickEffect">
+                                  <p:stCondLst>
+                                    <p:cond delay="0"/>
+                                  </p:stCondLst>
+                                  <p:childTnLst>
+                                    <p:set>
+                                      <p:cBhvr>
+                                        <p:cTn id="22" dur="1" fill="hold">
+                                          <p:stCondLst>
+                                            <p:cond delay="0"/>
+                                          </p:stCondLst>
+                                        </p:cTn>
+                                        <p:tgtEl>
+                                          <p:spTgt spid="12">
+                                            <p:txEl>
+                                              <p:pRg st="2" end="2"/>
+                                            </p:txEl>
+                                          </p:spTgt>
+                                        </p:tgtEl>
+                                        <p:attrNameLst>
+                                          <p:attrName>style.visibility</p:attrName>
+                                        </p:attrNameLst>
+                                      </p:cBhvr>
+                                      <p:to>
+                                        <p:strVal val="visible"/>
+                                      </p:to>
+                                    </p:set>
+                                  </p:childTnLst>
+                                </p:cTn>
+                              </p:par>
+                            </p:childTnLst>
+                          </p:cTn>
+                        </p:par>
+                      </p:childTnLst>
+                    </p:cTn>
+                  </p:par>
+                  <p:par>
+                    <p:cTn id="23" fill="hold">
+                      <p:stCondLst>
+                        <p:cond delay="indefinite"/>
+                      </p:stCondLst>
+                      <p:childTnLst>
+                        <p:par>
+                          <p:cTn id="24" fill="hold">
+                            <p:stCondLst>
+                              <p:cond delay="0"/>
+                            </p:stCondLst>
+                            <p:childTnLst>
+                              <p:par>
+                                <p:cTn id="25" presetID="1" presetClass="entr" presetSubtype="0" fill="hold" grpId="0" nodeType="clickEffect">
+                                  <p:stCondLst>
+                                    <p:cond delay="0"/>
+                                  </p:stCondLst>
+                                  <p:childTnLst>
+                                    <p:set>
+                                      <p:cBhvr>
+                                        <p:cTn id="26" dur="1" fill="hold">
+                                          <p:stCondLst>
+                                            <p:cond delay="0"/>
+                                          </p:stCondLst>
+                                        </p:cTn>
+                                        <p:tgtEl>
+                                          <p:spTgt spid="12">
+                                            <p:txEl>
+                                              <p:pRg st="3" end="3"/>
+                                            </p:txEl>
+                                          </p:spTgt>
+                                        </p:tgtEl>
+                                        <p:attrNameLst>
+                                          <p:attrName>style.visibility</p:attrName>
+                                        </p:attrNameLst>
+                                      </p:cBhvr>
+                                      <p:to>
+                                        <p:strVal val="visible"/>
+                                      </p:to>
+                                    </p:set>
+                                  </p:childTnLst>
+                                </p:cTn>
+                              </p:par>
+                              <p:par>
+                                <p:cTn id="27" presetID="1" presetClass="entr" presetSubtype="0" fill="hold" grpId="0" nodeType="withEffect">
+                                  <p:stCondLst>
+                                    <p:cond delay="0"/>
+                                  </p:stCondLst>
+                                  <p:childTnLst>
+                                    <p:set>
+                                      <p:cBhvr>
+                                        <p:cTn id="28" dur="1" fill="hold">
+                                          <p:stCondLst>
+                                            <p:cond delay="0"/>
+                                          </p:stCondLst>
+                                        </p:cTn>
+                                        <p:tgtEl>
+                                          <p:spTgt spid="12">
+                                            <p:txEl>
+                                              <p:pRg st="4" end="4"/>
+                                            </p:txEl>
+                                          </p:spTgt>
+                                        </p:tgtEl>
+                                        <p:attrNameLst>
+                                          <p:attrName>style.visibility</p:attrName>
+                                        </p:attrNameLst>
+                                      </p:cBhvr>
+                                      <p:to>
+                                        <p:strVal val="visible"/>
+                                      </p:to>
+                                    </p:set>
+                                  </p:childTnLst>
+                                </p:cTn>
+                              </p:par>
+                            </p:childTnLst>
+                          </p:cTn>
+                        </p:par>
+                      </p:childTnLst>
+                    </p:cTn>
+                  </p:par>
+                  <p:par>
+                    <p:cTn id="29" fill="hold">
+                      <p:stCondLst>
+                        <p:cond delay="indefinite"/>
+                      </p:stCondLst>
+                      <p:childTnLst>
+                        <p:par>
+                          <p:cTn id="30" fill="hold">
+                            <p:stCondLst>
+                              <p:cond delay="0"/>
+                            </p:stCondLst>
+                            <p:childTnLst>
+                              <p:par>
+                                <p:cTn id="31" presetID="1" presetClass="entr" presetSubtype="0" fill="hold" nodeType="clickEffect">
+                                  <p:stCondLst>
+                                    <p:cond delay="0"/>
+                                  </p:stCondLst>
+                                  <p:childTnLst>
+                                    <p:set>
+                                      <p:cBhvr>
+                                        <p:cTn id="32" dur="1" fill="hold">
+                                          <p:stCondLst>
+                                            <p:cond delay="0"/>
+                                          </p:stCondLst>
+                                        </p:cTn>
+                                        <p:tgtEl>
+                                          <p:spTgt spid="7"/>
+                                        </p:tgtEl>
+                                        <p:attrNameLst>
+                                          <p:attrName>style.visibility</p:attrName>
+                                        </p:attrNameLst>
+                                      </p:cBhvr>
+                                      <p:to>
+                                        <p:strVal val="visible"/>
+                                      </p:to>
+                                    </p:set>
+                                  </p:childTnLst>
+                                </p:cTn>
+                              </p:par>
+                            </p:childTnLst>
+                          </p:cTn>
+                        </p:par>
+                      </p:childTnLst>
+                    </p:cTn>
+                  </p:par>
+                  <p:par>
+                    <p:cTn id="33" fill="hold">
+                      <p:stCondLst>
+                        <p:cond delay="indefinite"/>
+                      </p:stCondLst>
+                      <p:childTnLst>
+                        <p:par>
+                          <p:cTn id="34" fill="hold">
+                            <p:stCondLst>
+                              <p:cond delay="0"/>
+                            </p:stCondLst>
+                            <p:childTnLst>
+                              <p:par>
+                                <p:cTn id="35" presetID="1" presetClass="entr" presetSubtype="0" fill="hold" nodeType="clickEffect">
+                                  <p:stCondLst>
+                                    <p:cond delay="0"/>
+                                  </p:stCondLst>
+                                  <p:childTnLst>
+                                    <p:set>
+                                      <p:cBhvr>
+                                        <p:cTn id="36" dur="1" fill="hold">
+                                          <p:stCondLst>
+                                            <p:cond delay="0"/>
+                                          </p:stCondLst>
+                                        </p:cTn>
+                                        <p:tgtEl>
+                                          <p:spTgt spid="16"/>
+                                        </p:tgtEl>
+                                        <p:attrNameLst>
+                                          <p:attrName>style.visibility</p:attrName>
+                                        </p:attrNameLst>
+                                      </p:cBhvr>
+                                      <p:to>
+                                        <p:strVal val="visible"/>
+                                      </p:to>
+                                    </p:set>
+                                  </p:childTnLst>
+                                </p:cTn>
+                              </p:par>
+                            </p:childTnLst>
+                          </p:cTn>
+                        </p:par>
+                      </p:childTnLst>
+                    </p:cTn>
+                  </p:par>
+                </p:childTnLst>
+              </p:cTn>
+              <p:prevCondLst>
+                <p:cond evt="onPrev" delay="0">
+                  <p:tgtEl>
+                    <p:sldTgt/>
+                  </p:tgtEl>
+                </p:cond>
+              </p:prevCondLst>
+              <p:nextCondLst>
+                <p:cond evt="onNext" delay="0">
+                  <p:tgtEl>
+                    <p:sldTgt/>
+                  </p:tgtEl>
+                </p:cond>
+              </p:nextCondLst>
+            </p:seq>
+          </p:childTnLst>
+        </p:cTn>
+      </p:par>
+    </p:tnLst>
+    <p:bldLst>
+      <p:bldP spid="10" grpId="0" build="p"/>
+      <p:bldP spid="12" grpId="0" build="p"/>
+    </p:bldLst>
+  </p:timing>
+</p:sld>
+</file>
+
+<file path=ppt/slides/slide18.xml><?xml version="1.0" encoding="utf-8"?>
+<p:sld xmlns:a="http://schemas.openxmlformats.org/drawingml/2006/main" xmlns:r="http://schemas.openxmlformats.org/officeDocument/2006/relationships" xmlns:p="http://schemas.openxmlformats.org/presentationml/2006/main">
+  <p:cSld>
+    <p:spTree>
+      <p:nvGrpSpPr>
+        <p:cNvPr id="1" name=""/>
+        <p:cNvGrpSpPr/>
+        <p:nvPr/>
+      </p:nvGrpSpPr>
+      <p:grpSpPr>
+        <a:xfrm>
+          <a:off x="0" y="0"/>
+          <a:ext cx="0" cy="0"/>
+          <a:chOff x="0" y="0"/>
+          <a:chExt cx="0" cy="0"/>
+        </a:xfrm>
+      </p:grpSpPr>
+      <p:sp>
+        <p:nvSpPr>
+          <p:cNvPr id="2" name="Title 1">
+            <a:extLst>
+              <a:ext uri="{FF2B5EF4-FFF2-40B4-BE49-F238E27FC236}">
+                <a16:creationId xmlns:a16="http://schemas.microsoft.com/office/drawing/2014/main" id="{BBD9DE93-9142-BE93-9409-508094E28F04}"/>
+              </a:ext>
+            </a:extLst>
+          </p:cNvPr>
+          <p:cNvSpPr>
+            <a:spLocks noGrp="1"/>
+          </p:cNvSpPr>
+          <p:nvPr>
+            <p:ph type="title"/>
+          </p:nvPr>
+        </p:nvSpPr>
+        <p:spPr/>
+        <p:txBody>
+          <a:bodyPr/>
+          <a:lstStyle/>
+          <a:p>
+            <a:r>
+              <a:rPr lang="en-US" dirty="0"/>
+              <a:t>Data hazard solution – forwarding</a:t>
+            </a:r>
+          </a:p>
+        </p:txBody>
+      </p:sp>
+      <p:sp>
+        <p:nvSpPr>
+          <p:cNvPr id="3" name="Content Placeholder 2">
+            <a:extLst>
+              <a:ext uri="{FF2B5EF4-FFF2-40B4-BE49-F238E27FC236}">
+                <a16:creationId xmlns:a16="http://schemas.microsoft.com/office/drawing/2014/main" id="{77E485F3-EBD2-0953-1741-21C5C52407DF}"/>
+              </a:ext>
+            </a:extLst>
+          </p:cNvPr>
+          <p:cNvSpPr>
+            <a:spLocks noGrp="1"/>
+          </p:cNvSpPr>
+          <p:nvPr>
+            <p:ph idx="1"/>
+          </p:nvPr>
+        </p:nvSpPr>
+        <p:spPr>
+          <a:xfrm>
+            <a:off x="94576" y="1371600"/>
+            <a:ext cx="8972549" cy="1929075"/>
+          </a:xfrm>
+        </p:spPr>
+        <p:txBody>
+          <a:bodyPr>
+            <a:normAutofit fontScale="92500" lnSpcReduction="10000"/>
+          </a:bodyPr>
+          <a:lstStyle/>
+          <a:p>
+            <a:pPr marL="0" indent="0">
+              <a:buNone/>
+            </a:pPr>
+            <a:r>
+              <a:rPr lang="en-US" dirty="0"/>
+              <a:t>Forwarding:</a:t>
+            </a:r>
+          </a:p>
+          <a:p>
+            <a:pPr marL="514350" indent="-514350">
+              <a:buAutoNum type="arabicPeriod"/>
+            </a:pPr>
+            <a:r>
+              <a:rPr lang="en-US" dirty="0"/>
+              <a:t>Data already available in cycle 3</a:t>
+            </a:r>
+          </a:p>
+          <a:p>
+            <a:pPr marL="514350" indent="-514350">
+              <a:buAutoNum type="arabicPeriod"/>
+            </a:pPr>
+            <a:r>
+              <a:rPr lang="en-US" dirty="0"/>
+              <a:t>Grab it from pipeline stage, rather than waiting to update the register file</a:t>
+            </a:r>
+          </a:p>
+        </p:txBody>
+      </p:sp>
+      <p:sp>
+        <p:nvSpPr>
+          <p:cNvPr id="4" name="Date Placeholder 3">
+            <a:extLst>
+              <a:ext uri="{FF2B5EF4-FFF2-40B4-BE49-F238E27FC236}">
+                <a16:creationId xmlns:a16="http://schemas.microsoft.com/office/drawing/2014/main" id="{AA86B360-2714-46D5-2DCC-75FD416FA166}"/>
+              </a:ext>
+            </a:extLst>
+          </p:cNvPr>
+          <p:cNvSpPr>
+            <a:spLocks noGrp="1"/>
+          </p:cNvSpPr>
+          <p:nvPr>
+            <p:ph type="dt" sz="half" idx="10"/>
+          </p:nvPr>
+        </p:nvSpPr>
+        <p:spPr/>
+        <p:txBody>
+          <a:bodyPr/>
+          <a:lstStyle/>
+          <a:p>
+            <a:fld id="{B4B13859-67C5-4393-B6C2-556CF3F770C0}" type="datetime3">
+              <a:rPr lang="en-US" smtClean="0"/>
+              <a:t>23 February 2026</a:t>
+            </a:fld>
+            <a:endParaRPr lang="en-US"/>
+          </a:p>
+        </p:txBody>
+      </p:sp>
+      <p:sp>
+        <p:nvSpPr>
+          <p:cNvPr id="6" name="Slide Number Placeholder 5">
+            <a:extLst>
+              <a:ext uri="{FF2B5EF4-FFF2-40B4-BE49-F238E27FC236}">
+                <a16:creationId xmlns:a16="http://schemas.microsoft.com/office/drawing/2014/main" id="{1C11FBBF-2726-6975-CA40-5CC9BBB0EA8A}"/>
+              </a:ext>
+            </a:extLst>
+          </p:cNvPr>
+          <p:cNvSpPr>
+            <a:spLocks noGrp="1"/>
+          </p:cNvSpPr>
+          <p:nvPr>
+            <p:ph type="sldNum" sz="quarter" idx="12"/>
+          </p:nvPr>
+        </p:nvSpPr>
+        <p:spPr/>
+        <p:txBody>
+          <a:bodyPr/>
+          <a:lstStyle/>
+          <a:p>
+            <a:fld id="{98AC3541-01C1-4CA5-B68F-FEE868C7D1AF}" type="slidenum">
+              <a:rPr lang="en-US" smtClean="0"/>
+              <a:t>18</a:t>
+            </a:fld>
+            <a:endParaRPr lang="en-US"/>
+          </a:p>
+        </p:txBody>
+      </p:sp>
+      <p:pic>
+        <p:nvPicPr>
+          <p:cNvPr id="8" name="Picture 7">
+            <a:extLst>
+              <a:ext uri="{FF2B5EF4-FFF2-40B4-BE49-F238E27FC236}">
+                <a16:creationId xmlns:a16="http://schemas.microsoft.com/office/drawing/2014/main" id="{25CFB899-4B76-5D86-9380-69A57630159F}"/>
+              </a:ext>
+            </a:extLst>
+          </p:cNvPr>
+          <p:cNvPicPr>
+            <a:picLocks noChangeAspect="1"/>
+          </p:cNvPicPr>
+          <p:nvPr/>
+        </p:nvPicPr>
+        <p:blipFill>
+          <a:blip r:embed="rId2"/>
+          <a:stretch>
+            <a:fillRect/>
+          </a:stretch>
+        </p:blipFill>
+        <p:spPr>
+          <a:xfrm>
+            <a:off x="488952" y="3557324"/>
+            <a:ext cx="5651495" cy="2564964"/>
+          </a:xfrm>
+          <a:prstGeom prst="rect">
+            <a:avLst/>
+          </a:prstGeom>
+        </p:spPr>
+      </p:pic>
+      <p:sp>
+        <p:nvSpPr>
+          <p:cNvPr id="9" name="Content Placeholder 2">
+            <a:extLst>
+              <a:ext uri="{FF2B5EF4-FFF2-40B4-BE49-F238E27FC236}">
+                <a16:creationId xmlns:a16="http://schemas.microsoft.com/office/drawing/2014/main" id="{C202BC39-15D1-8BFA-0A13-92033EC77F3A}"/>
+              </a:ext>
+            </a:extLst>
+          </p:cNvPr>
+          <p:cNvSpPr txBox="1">
+            <a:spLocks/>
+          </p:cNvSpPr>
+          <p:nvPr/>
+        </p:nvSpPr>
+        <p:spPr>
+          <a:xfrm>
+            <a:off x="5334000" y="3557324"/>
+            <a:ext cx="3540443" cy="1143000"/>
+          </a:xfrm>
+          <a:prstGeom prst="rect">
+            <a:avLst/>
+          </a:prstGeom>
+        </p:spPr>
+        <p:txBody>
+          <a:bodyPr vert="horz" lIns="68580" tIns="34290" rIns="68580" bIns="34290" rtlCol="0">
+            <a:normAutofit/>
+          </a:bodyPr>
+          <a:lstStyle>
+            <a:lvl1pPr marL="228600" indent="-228600" algn="l" defTabSz="914400" rtl="0" eaLnBrk="1" latinLnBrk="0" hangingPunct="1">
+              <a:lnSpc>
+                <a:spcPct val="90000"/>
+              </a:lnSpc>
+              <a:spcBef>
+                <a:spcPts val="1000"/>
+              </a:spcBef>
+              <a:buFont typeface="Arial" panose="020B0604020202020204" pitchFamily="34" charset="0"/>
+              <a:buChar char="•"/>
+              <a:defRPr sz="2400" kern="1200">
+                <a:solidFill>
+                  <a:schemeClr val="tx1"/>
+                </a:solidFill>
+                <a:latin typeface="+mn-lt"/>
+                <a:ea typeface="+mn-ea"/>
+                <a:cs typeface="+mn-cs"/>
+              </a:defRPr>
+            </a:lvl1pPr>
+            <a:lvl2pPr marL="685800" indent="-228600" algn="l" defTabSz="914400" rtl="0" eaLnBrk="1" latinLnBrk="0" hangingPunct="1">
+              <a:lnSpc>
+                <a:spcPct val="90000"/>
+              </a:lnSpc>
+              <a:spcBef>
+                <a:spcPts val="500"/>
+              </a:spcBef>
+              <a:buFont typeface="Arial" panose="020B0604020202020204" pitchFamily="34" charset="0"/>
+              <a:buChar char="•"/>
+              <a:defRPr sz="2000" kern="1200">
+                <a:solidFill>
+                  <a:schemeClr val="tx1"/>
+                </a:solidFill>
+                <a:latin typeface="+mn-lt"/>
+                <a:ea typeface="+mn-ea"/>
+                <a:cs typeface="+mn-cs"/>
+              </a:defRPr>
+            </a:lvl2pPr>
+            <a:lvl3pPr marL="1143000" indent="-228600" algn="l" defTabSz="914400" rtl="0" eaLnBrk="1" latinLnBrk="0" hangingPunct="1">
+              <a:lnSpc>
+                <a:spcPct val="90000"/>
+              </a:lnSpc>
+              <a:spcBef>
+                <a:spcPts val="500"/>
+              </a:spcBef>
+              <a:buFont typeface="Arial" panose="020B0604020202020204" pitchFamily="34" charset="0"/>
+              <a:buChar char="•"/>
+              <a:defRPr sz="1800" kern="1200">
+                <a:solidFill>
+                  <a:schemeClr val="tx1"/>
+                </a:solidFill>
+                <a:latin typeface="+mn-lt"/>
+                <a:ea typeface="+mn-ea"/>
+                <a:cs typeface="+mn-cs"/>
+              </a:defRPr>
+            </a:lvl3pPr>
+            <a:lvl4pPr marL="1600200" indent="-228600" algn="l" defTabSz="914400" rtl="0" eaLnBrk="1" latinLnBrk="0" hangingPunct="1">
+              <a:lnSpc>
+                <a:spcPct val="90000"/>
+              </a:lnSpc>
+              <a:spcBef>
+                <a:spcPts val="500"/>
+              </a:spcBef>
+              <a:buFont typeface="Arial" panose="020B0604020202020204" pitchFamily="34" charset="0"/>
+              <a:buChar char="•"/>
+              <a:defRPr sz="1600" kern="1200">
+                <a:solidFill>
+                  <a:schemeClr val="tx1"/>
+                </a:solidFill>
+                <a:latin typeface="+mn-lt"/>
+                <a:ea typeface="+mn-ea"/>
+                <a:cs typeface="+mn-cs"/>
+              </a:defRPr>
+            </a:lvl4pPr>
+            <a:lvl5pPr marL="2057400" indent="-228600" algn="l" defTabSz="914400" rtl="0" eaLnBrk="1" latinLnBrk="0" hangingPunct="1">
+              <a:lnSpc>
+                <a:spcPct val="90000"/>
+              </a:lnSpc>
+              <a:spcBef>
+                <a:spcPts val="500"/>
+              </a:spcBef>
+              <a:buFont typeface="Arial" panose="020B0604020202020204" pitchFamily="34" charset="0"/>
+              <a:buChar char="•"/>
+              <a:defRPr sz="1600" kern="1200">
+                <a:solidFill>
+                  <a:schemeClr val="tx1"/>
+                </a:solidFill>
+                <a:latin typeface="+mn-lt"/>
+                <a:ea typeface="+mn-ea"/>
+                <a:cs typeface="+mn-cs"/>
+              </a:defRPr>
+            </a:lvl5pPr>
+            <a:lvl6pPr marL="2514600" indent="-228600" algn="l" defTabSz="914400" rtl="0" eaLnBrk="1" latinLnBrk="0" hangingPunct="1">
+              <a:lnSpc>
+                <a:spcPct val="90000"/>
+              </a:lnSpc>
+              <a:spcBef>
+                <a:spcPts val="500"/>
+              </a:spcBef>
+              <a:buFont typeface="Arial" panose="020B0604020202020204" pitchFamily="34" charset="0"/>
+              <a:buChar char="•"/>
+              <a:defRPr sz="1800" kern="1200">
+                <a:solidFill>
+                  <a:schemeClr val="tx1"/>
+                </a:solidFill>
+                <a:latin typeface="+mn-lt"/>
+                <a:ea typeface="+mn-ea"/>
+                <a:cs typeface="+mn-cs"/>
+              </a:defRPr>
+            </a:lvl6pPr>
+            <a:lvl7pPr marL="2971800" indent="-228600" algn="l" defTabSz="914400" rtl="0" eaLnBrk="1" latinLnBrk="0" hangingPunct="1">
+              <a:lnSpc>
+                <a:spcPct val="90000"/>
+              </a:lnSpc>
+              <a:spcBef>
+                <a:spcPts val="500"/>
+              </a:spcBef>
+              <a:buFont typeface="Arial" panose="020B0604020202020204" pitchFamily="34" charset="0"/>
+              <a:buChar char="•"/>
+              <a:defRPr sz="1800" kern="1200">
+                <a:solidFill>
+                  <a:schemeClr val="tx1"/>
+                </a:solidFill>
+                <a:latin typeface="+mn-lt"/>
+                <a:ea typeface="+mn-ea"/>
+                <a:cs typeface="+mn-cs"/>
+              </a:defRPr>
+            </a:lvl7pPr>
+            <a:lvl8pPr marL="3429000" indent="-228600" algn="l" defTabSz="914400" rtl="0" eaLnBrk="1" latinLnBrk="0" hangingPunct="1">
+              <a:lnSpc>
+                <a:spcPct val="90000"/>
+              </a:lnSpc>
+              <a:spcBef>
+                <a:spcPts val="500"/>
+              </a:spcBef>
+              <a:buFont typeface="Arial" panose="020B0604020202020204" pitchFamily="34" charset="0"/>
+              <a:buChar char="•"/>
+              <a:defRPr sz="1800" kern="1200">
+                <a:solidFill>
+                  <a:schemeClr val="tx1"/>
+                </a:solidFill>
+                <a:latin typeface="+mn-lt"/>
+                <a:ea typeface="+mn-ea"/>
+                <a:cs typeface="+mn-cs"/>
+              </a:defRPr>
+            </a:lvl8pPr>
+            <a:lvl9pPr marL="3886200" indent="-228600" algn="l" defTabSz="914400" rtl="0" eaLnBrk="1" latinLnBrk="0" hangingPunct="1">
+              <a:lnSpc>
+                <a:spcPct val="90000"/>
+              </a:lnSpc>
+              <a:spcBef>
+                <a:spcPts val="500"/>
+              </a:spcBef>
+              <a:buFont typeface="Arial" panose="020B0604020202020204" pitchFamily="34" charset="0"/>
+              <a:buChar char="•"/>
+              <a:defRPr sz="1800" kern="1200">
+                <a:solidFill>
+                  <a:schemeClr val="tx1"/>
+                </a:solidFill>
+                <a:latin typeface="+mn-lt"/>
+                <a:ea typeface="+mn-ea"/>
+                <a:cs typeface="+mn-cs"/>
+              </a:defRPr>
+            </a:lvl9pPr>
+          </a:lstStyle>
+          <a:p>
+            <a:pPr marL="0" indent="0">
+              <a:buNone/>
+            </a:pPr>
+            <a:r>
+              <a:rPr lang="en-US" sz="1800" b="1" dirty="0">
+                <a:solidFill>
+                  <a:srgbClr val="FFC000"/>
+                </a:solidFill>
+              </a:rPr>
+              <a:t>Needs changes in </a:t>
+            </a:r>
+            <a:r>
+              <a:rPr lang="en-US" sz="1800" b="1" dirty="0" err="1">
+                <a:solidFill>
+                  <a:srgbClr val="FFC000"/>
+                </a:solidFill>
+              </a:rPr>
+              <a:t>datapath</a:t>
+            </a:r>
+            <a:r>
+              <a:rPr lang="en-US" sz="1800" b="1" dirty="0">
+                <a:solidFill>
+                  <a:srgbClr val="FFC000"/>
+                </a:solidFill>
+              </a:rPr>
+              <a:t> hardware as well as extra control signals!</a:t>
+            </a:r>
+          </a:p>
+        </p:txBody>
+      </p:sp>
+    </p:spTree>
+    <p:extLst>
+      <p:ext uri="{BB962C8B-B14F-4D97-AF65-F5344CB8AC3E}">
+        <p14:creationId xmlns:p14="http://schemas.microsoft.com/office/powerpoint/2010/main" val="2886565167"/>
+      </p:ext>
+    </p:extLst>
+  </p:cSld>
+  <p:clrMapOvr>
+    <a:masterClrMapping/>
+  </p:clrMapOvr>
+  <p:timing>
+    <p:tnLst>
+      <p:par>
+        <p:cTn id="1" dur="indefinite" restart="never" nodeType="tmRoot">
+          <p:childTnLst>
+            <p:seq concurrent="1" nextAc="seek">
+              <p:cTn id="2" dur="indefinite" nodeType="mainSeq">
+                <p:childTnLst>
+                  <p:par>
+                    <p:cTn id="3" fill="hold">
+                      <p:stCondLst>
+                        <p:cond delay="indefinite"/>
+                      </p:stCondLst>
+                      <p:childTnLst>
+                        <p:par>
+                          <p:cTn id="4" fill="hold">
+                            <p:stCondLst>
+                              <p:cond delay="0"/>
+                            </p:stCondLst>
+                            <p:childTnLst>
+                              <p:par>
+                                <p:cTn id="5" presetID="1" presetClass="entr" presetSubtype="0" fill="hold" grpId="0" nodeType="clickEffect">
+                                  <p:stCondLst>
+                                    <p:cond delay="0"/>
+                                  </p:stCondLst>
+                                  <p:childTnLst>
+                                    <p:set>
+                                      <p:cBhvr>
+                                        <p:cTn id="6" dur="1" fill="hold">
+                                          <p:stCondLst>
+                                            <p:cond delay="0"/>
+                                          </p:stCondLst>
+                                        </p:cTn>
+                                        <p:tgtEl>
+                                          <p:spTgt spid="3">
+                                            <p:txEl>
+                                              <p:pRg st="0" end="0"/>
+                                            </p:txEl>
+                                          </p:spTgt>
+                                        </p:tgtEl>
+                                        <p:attrNameLst>
+                                          <p:attrName>style.visibility</p:attrName>
+                                        </p:attrNameLst>
+                                      </p:cBhvr>
+                                      <p:to>
+                                        <p:strVal val="visible"/>
+                                      </p:to>
+                                    </p:set>
+                                  </p:childTnLst>
+                                </p:cTn>
+                              </p:par>
+                            </p:childTnLst>
+                          </p:cTn>
+                        </p:par>
+                      </p:childTnLst>
+                    </p:cTn>
+                  </p:par>
+                  <p:par>
+                    <p:cTn id="7" fill="hold">
+                      <p:stCondLst>
+                        <p:cond delay="indefinite"/>
+                      </p:stCondLst>
+                      <p:childTnLst>
+                        <p:par>
+                          <p:cTn id="8" fill="hold">
+                            <p:stCondLst>
+                              <p:cond delay="0"/>
+                            </p:stCondLst>
+                            <p:childTnLst>
+                              <p:par>
+                                <p:cTn id="9" presetID="1" presetClass="entr" presetSubtype="0" fill="hold" grpId="0" nodeType="clickEffect">
+                                  <p:stCondLst>
+                                    <p:cond delay="0"/>
+                                  </p:stCondLst>
+                                  <p:childTnLst>
+                                    <p:set>
+                                      <p:cBhvr>
+                                        <p:cTn id="10" dur="1" fill="hold">
+                                          <p:stCondLst>
+                                            <p:cond delay="0"/>
+                                          </p:stCondLst>
+                                        </p:cTn>
+                                        <p:tgtEl>
+                                          <p:spTgt spid="3">
+                                            <p:txEl>
+                                              <p:pRg st="1" end="1"/>
+                                            </p:txEl>
+                                          </p:spTgt>
+                                        </p:tgtEl>
+                                        <p:attrNameLst>
+                                          <p:attrName>style.visibility</p:attrName>
+                                        </p:attrNameLst>
+                                      </p:cBhvr>
+                                      <p:to>
+                                        <p:strVal val="visible"/>
+                                      </p:to>
+                                    </p:set>
+                                  </p:childTnLst>
+                                </p:cTn>
+                              </p:par>
+                            </p:childTnLst>
+                          </p:cTn>
+                        </p:par>
+                      </p:childTnLst>
+                    </p:cTn>
+                  </p:par>
+                  <p:par>
+                    <p:cTn id="11" fill="hold">
+                      <p:stCondLst>
+                        <p:cond delay="indefinite"/>
+                      </p:stCondLst>
+                      <p:childTnLst>
+                        <p:par>
+                          <p:cTn id="12" fill="hold">
+                            <p:stCondLst>
+                              <p:cond delay="0"/>
+                            </p:stCondLst>
+                            <p:childTnLst>
+                              <p:par>
+                                <p:cTn id="13" presetID="1" presetClass="entr" presetSubtype="0" fill="hold" grpId="0" nodeType="clickEffect">
+                                  <p:stCondLst>
+                                    <p:cond delay="0"/>
+                                  </p:stCondLst>
+                                  <p:childTnLst>
+                                    <p:set>
+                                      <p:cBhvr>
+                                        <p:cTn id="14" dur="1" fill="hold">
+                                          <p:stCondLst>
+                                            <p:cond delay="0"/>
+                                          </p:stCondLst>
+                                        </p:cTn>
+                                        <p:tgtEl>
+                                          <p:spTgt spid="3">
+                                            <p:txEl>
+                                              <p:pRg st="2" end="2"/>
+                                            </p:txEl>
+                                          </p:spTgt>
+                                        </p:tgtEl>
+                                        <p:attrNameLst>
+                                          <p:attrName>style.visibility</p:attrName>
+                                        </p:attrNameLst>
+                                      </p:cBhvr>
+                                      <p:to>
+                                        <p:strVal val="visible"/>
+                                      </p:to>
+                                    </p:set>
+                                  </p:childTnLst>
+                                </p:cTn>
+                              </p:par>
+                            </p:childTnLst>
+                          </p:cTn>
+                        </p:par>
+                      </p:childTnLst>
+                    </p:cTn>
+                  </p:par>
+                  <p:par>
+                    <p:cTn id="15" fill="hold">
+                      <p:stCondLst>
+                        <p:cond delay="indefinite"/>
+                      </p:stCondLst>
+                      <p:childTnLst>
+                        <p:par>
+                          <p:cTn id="16" fill="hold">
+                            <p:stCondLst>
+                              <p:cond delay="0"/>
+                            </p:stCondLst>
+                            <p:childTnLst>
+                              <p:par>
+                                <p:cTn id="17" presetID="1" presetClass="entr" presetSubtype="0" fill="hold" nodeType="clickEffect">
+                                  <p:stCondLst>
+                                    <p:cond delay="0"/>
+                                  </p:stCondLst>
+                                  <p:childTnLst>
+                                    <p:set>
+                                      <p:cBhvr>
+                                        <p:cTn id="18" dur="1" fill="hold">
+                                          <p:stCondLst>
+                                            <p:cond delay="0"/>
+                                          </p:stCondLst>
+                                        </p:cTn>
+                                        <p:tgtEl>
+                                          <p:spTgt spid="8"/>
+                                        </p:tgtEl>
+                                        <p:attrNameLst>
+                                          <p:attrName>style.visibility</p:attrName>
+                                        </p:attrNameLst>
+                                      </p:cBhvr>
+                                      <p:to>
+                                        <p:strVal val="visible"/>
+                                      </p:to>
+                                    </p:set>
+                                  </p:childTnLst>
+                                </p:cTn>
+                              </p:par>
+                            </p:childTnLst>
+                          </p:cTn>
+                        </p:par>
+                      </p:childTnLst>
+                    </p:cTn>
+                  </p:par>
+                  <p:par>
+                    <p:cTn id="19" fill="hold">
+                      <p:stCondLst>
+                        <p:cond delay="indefinite"/>
+                      </p:stCondLst>
+                      <p:childTnLst>
+                        <p:par>
+                          <p:cTn id="20" fill="hold">
+                            <p:stCondLst>
+                              <p:cond delay="0"/>
+                            </p:stCondLst>
+                            <p:childTnLst>
+                              <p:par>
+                                <p:cTn id="21" presetID="1" presetClass="entr" presetSubtype="0" fill="hold" grpId="0" nodeType="clickEffect">
+                                  <p:stCondLst>
+                                    <p:cond delay="0"/>
+                                  </p:stCondLst>
+                                  <p:childTnLst>
+                                    <p:set>
+                                      <p:cBhvr>
+                                        <p:cTn id="22" dur="1" fill="hold">
+                                          <p:stCondLst>
+                                            <p:cond delay="0"/>
+                                          </p:stCondLst>
+                                        </p:cTn>
+                                        <p:tgtEl>
+                                          <p:spTgt spid="9"/>
+                                        </p:tgtEl>
+                                        <p:attrNameLst>
+                                          <p:attrName>style.visibility</p:attrName>
+                                        </p:attrNameLst>
+                                      </p:cBhvr>
+                                      <p:to>
+                                        <p:strVal val="visible"/>
+                                      </p:to>
+                                    </p:set>
+                                  </p:childTnLst>
+                                </p:cTn>
+                              </p:par>
+                            </p:childTnLst>
+                          </p:cTn>
+                        </p:par>
+                      </p:childTnLst>
+                    </p:cTn>
+                  </p:par>
+                </p:childTnLst>
+              </p:cTn>
+              <p:prevCondLst>
+                <p:cond evt="onPrev" delay="0">
+                  <p:tgtEl>
+                    <p:sldTgt/>
+                  </p:tgtEl>
+                </p:cond>
+              </p:prevCondLst>
+              <p:nextCondLst>
+                <p:cond evt="onNext" delay="0">
+                  <p:tgtEl>
+                    <p:sldTgt/>
+                  </p:tgtEl>
+                </p:cond>
+              </p:nextCondLst>
+            </p:seq>
+          </p:childTnLst>
+        </p:cTn>
+      </p:par>
+    </p:tnLst>
+    <p:bldLst>
+      <p:bldP spid="3" grpId="0" build="p"/>
+      <p:bldP spid="9" grpId="0"/>
+    </p:bldLst>
+  </p:timing>
+</p:sld>
+</file>
+
+<file path=ppt/slides/slide19.xml><?xml version="1.0" encoding="utf-8"?>
+<p:sld xmlns:a="http://schemas.openxmlformats.org/drawingml/2006/main" xmlns:r="http://schemas.openxmlformats.org/officeDocument/2006/relationships" xmlns:p="http://schemas.openxmlformats.org/presentationml/2006/main">
+  <p:cSld>
+    <p:spTree>
+      <p:nvGrpSpPr>
+        <p:cNvPr id="1" name=""/>
+        <p:cNvGrpSpPr/>
+        <p:nvPr/>
+      </p:nvGrpSpPr>
+      <p:grpSpPr>
+        <a:xfrm>
+          <a:off x="0" y="0"/>
+          <a:ext cx="0" cy="0"/>
+          <a:chOff x="0" y="0"/>
+          <a:chExt cx="0" cy="0"/>
+        </a:xfrm>
+      </p:grpSpPr>
+      <p:sp>
+        <p:nvSpPr>
+          <p:cNvPr id="2" name="Title 1">
+            <a:extLst>
+              <a:ext uri="{FF2B5EF4-FFF2-40B4-BE49-F238E27FC236}">
+                <a16:creationId xmlns:a16="http://schemas.microsoft.com/office/drawing/2014/main" id="{09EC1025-E879-AF40-2767-F8956232F5B5}"/>
+              </a:ext>
+            </a:extLst>
+          </p:cNvPr>
+          <p:cNvSpPr>
+            <a:spLocks noGrp="1"/>
+          </p:cNvSpPr>
+          <p:nvPr>
+            <p:ph type="title"/>
+          </p:nvPr>
+        </p:nvSpPr>
+        <p:spPr/>
+        <p:txBody>
+          <a:bodyPr/>
+          <a:lstStyle/>
+          <a:p>
+            <a:r>
+              <a:rPr lang="en-US" dirty="0"/>
+              <a:t>Data hazard solution – forwarding</a:t>
+            </a:r>
+          </a:p>
+        </p:txBody>
+      </p:sp>
+      <p:pic>
+        <p:nvPicPr>
+          <p:cNvPr id="8" name="Content Placeholder 7">
+            <a:extLst>
+              <a:ext uri="{FF2B5EF4-FFF2-40B4-BE49-F238E27FC236}">
+                <a16:creationId xmlns:a16="http://schemas.microsoft.com/office/drawing/2014/main" id="{FDF9E3D3-7A51-7CA8-0349-E3F2A7E81DA4}"/>
+              </a:ext>
+            </a:extLst>
+          </p:cNvPr>
+          <p:cNvPicPr>
+            <a:picLocks noGrp="1" noChangeAspect="1"/>
+          </p:cNvPicPr>
+          <p:nvPr>
+            <p:ph idx="1"/>
+          </p:nvPr>
+        </p:nvPicPr>
+        <p:blipFill rotWithShape="1">
+          <a:blip r:embed="rId2"/>
+          <a:srcRect t="-1922"/>
+          <a:stretch>
+            <a:fillRect/>
+          </a:stretch>
+        </p:blipFill>
+        <p:spPr>
+          <a:xfrm>
+            <a:off x="875010" y="1524000"/>
+            <a:ext cx="7393980" cy="4876800"/>
+          </a:xfrm>
+        </p:spPr>
+      </p:pic>
+      <p:sp>
+        <p:nvSpPr>
+          <p:cNvPr id="4" name="Date Placeholder 3">
+            <a:extLst>
+              <a:ext uri="{FF2B5EF4-FFF2-40B4-BE49-F238E27FC236}">
+                <a16:creationId xmlns:a16="http://schemas.microsoft.com/office/drawing/2014/main" id="{CA14E1D7-3CFC-102F-BBAC-BD8A566C9A78}"/>
+              </a:ext>
+            </a:extLst>
+          </p:cNvPr>
+          <p:cNvSpPr>
+            <a:spLocks noGrp="1"/>
+          </p:cNvSpPr>
+          <p:nvPr>
+            <p:ph type="dt" sz="half" idx="10"/>
+          </p:nvPr>
+        </p:nvSpPr>
+        <p:spPr/>
+        <p:txBody>
+          <a:bodyPr/>
+          <a:lstStyle/>
+          <a:p>
+            <a:fld id="{B4B13859-67C5-4393-B6C2-556CF3F770C0}" type="datetime3">
+              <a:rPr lang="en-US" smtClean="0"/>
+              <a:t>23 February 2026</a:t>
+            </a:fld>
+            <a:endParaRPr lang="en-US"/>
+          </a:p>
+        </p:txBody>
+      </p:sp>
+      <p:sp>
+        <p:nvSpPr>
+          <p:cNvPr id="6" name="Slide Number Placeholder 5">
+            <a:extLst>
+              <a:ext uri="{FF2B5EF4-FFF2-40B4-BE49-F238E27FC236}">
+                <a16:creationId xmlns:a16="http://schemas.microsoft.com/office/drawing/2014/main" id="{B966C9E2-76C6-1273-B5FC-72EEBCEC114E}"/>
+              </a:ext>
+            </a:extLst>
+          </p:cNvPr>
+          <p:cNvSpPr>
+            <a:spLocks noGrp="1"/>
+          </p:cNvSpPr>
+          <p:nvPr>
+            <p:ph type="sldNum" sz="quarter" idx="12"/>
+          </p:nvPr>
+        </p:nvSpPr>
+        <p:spPr/>
+        <p:txBody>
+          <a:bodyPr/>
+          <a:lstStyle/>
+          <a:p>
+            <a:fld id="{98AC3541-01C1-4CA5-B68F-FEE868C7D1AF}" type="slidenum">
+              <a:rPr lang="en-US" smtClean="0"/>
+              <a:t>19</a:t>
+            </a:fld>
+            <a:endParaRPr lang="en-US"/>
+          </a:p>
+        </p:txBody>
+      </p:sp>
+    </p:spTree>
+    <p:extLst>
+      <p:ext uri="{BB962C8B-B14F-4D97-AF65-F5344CB8AC3E}">
+        <p14:creationId xmlns:p14="http://schemas.microsoft.com/office/powerpoint/2010/main" val="3419635446"/>
+      </p:ext>
+    </p:extLst>
+  </p:cSld>
+  <p:clrMapOvr>
+    <a:masterClrMapping/>
+  </p:clrMapOvr>
+</p:sld>
+</file>
+
 <file path=ppt/slides/slide2.xml><?xml version="1.0" encoding="utf-8"?>
 <p:sld xmlns:a="http://schemas.openxmlformats.org/drawingml/2006/main" xmlns:r="http://schemas.openxmlformats.org/officeDocument/2006/relationships" xmlns:p="http://schemas.openxmlformats.org/presentationml/2006/main">
   <p:cSld>
@@ -8618,7 +11342,7 @@
           <a:p>
             <a:fld id="{B4B13859-67C5-4393-B6C2-556CF3F770C0}" type="datetime3">
               <a:rPr lang="en-US" smtClean="0"/>
-              <a:t>20 February 2026</a:t>
+              <a:t>23 February 2026</a:t>
             </a:fld>
             <a:endParaRPr lang="en-US" dirty="0"/>
           </a:p>
@@ -8915,6 +11639,831 @@
 </p:sld>
 </file>
 
+<file path=ppt/slides/slide20.xml><?xml version="1.0" encoding="utf-8"?>
+<p:sld xmlns:a="http://schemas.openxmlformats.org/drawingml/2006/main" xmlns:r="http://schemas.openxmlformats.org/officeDocument/2006/relationships" xmlns:p="http://schemas.openxmlformats.org/presentationml/2006/main">
+  <p:cSld>
+    <p:spTree>
+      <p:nvGrpSpPr>
+        <p:cNvPr id="1" name=""/>
+        <p:cNvGrpSpPr/>
+        <p:nvPr/>
+      </p:nvGrpSpPr>
+      <p:grpSpPr>
+        <a:xfrm>
+          <a:off x="0" y="0"/>
+          <a:ext cx="0" cy="0"/>
+          <a:chOff x="0" y="0"/>
+          <a:chExt cx="0" cy="0"/>
+        </a:xfrm>
+      </p:grpSpPr>
+      <p:pic>
+        <p:nvPicPr>
+          <p:cNvPr id="3" name="Content Placeholder 7">
+            <a:extLst>
+              <a:ext uri="{FF2B5EF4-FFF2-40B4-BE49-F238E27FC236}">
+                <a16:creationId xmlns:a16="http://schemas.microsoft.com/office/drawing/2014/main" id="{A11395B8-9AC4-2E17-6D1B-4286633A1763}"/>
+              </a:ext>
+            </a:extLst>
+          </p:cNvPr>
+          <p:cNvPicPr>
+            <a:picLocks noChangeAspect="1"/>
+          </p:cNvPicPr>
+          <p:nvPr/>
+        </p:nvPicPr>
+        <p:blipFill rotWithShape="1">
+          <a:blip r:embed="rId2"/>
+          <a:srcRect/>
+          <a:stretch>
+            <a:fillRect/>
+          </a:stretch>
+        </p:blipFill>
+        <p:spPr bwMode="auto">
+          <a:xfrm>
+            <a:off x="139262" y="1910455"/>
+            <a:ext cx="4679038" cy="1421560"/>
+          </a:xfrm>
+          <a:prstGeom prst="rect">
+            <a:avLst/>
+          </a:prstGeom>
+          <a:noFill/>
+          <a:ln>
+            <a:noFill/>
+          </a:ln>
+          <a:extLst>
+            <a:ext uri="{909E8E84-426E-40DD-AFC4-6F175D3DCCD1}">
+              <a14:hiddenFill xmlns:a14="http://schemas.microsoft.com/office/drawing/2010/main">
+                <a:solidFill>
+                  <a:srgbClr val="FFFFFF"/>
+                </a:solidFill>
+              </a14:hiddenFill>
+            </a:ext>
+            <a:ext uri="{91240B29-F687-4F45-9708-019B960494DF}">
+              <a14:hiddenLine xmlns:a14="http://schemas.microsoft.com/office/drawing/2010/main" w="9525">
+                <a:solidFill>
+                  <a:srgbClr val="000000"/>
+                </a:solidFill>
+                <a:miter lim="800000"/>
+                <a:headEnd/>
+                <a:tailEnd/>
+              </a14:hiddenLine>
+            </a:ext>
+          </a:extLst>
+        </p:spPr>
+      </p:pic>
+      <p:sp>
+        <p:nvSpPr>
+          <p:cNvPr id="2" name="Title 1">
+            <a:extLst>
+              <a:ext uri="{FF2B5EF4-FFF2-40B4-BE49-F238E27FC236}">
+                <a16:creationId xmlns:a16="http://schemas.microsoft.com/office/drawing/2014/main" id="{62A7B986-5846-200C-0158-F8175DE15098}"/>
+              </a:ext>
+            </a:extLst>
+          </p:cNvPr>
+          <p:cNvSpPr>
+            <a:spLocks noGrp="1"/>
+          </p:cNvSpPr>
+          <p:nvPr>
+            <p:ph type="title"/>
+          </p:nvPr>
+        </p:nvSpPr>
+        <p:spPr/>
+        <p:txBody>
+          <a:bodyPr/>
+          <a:lstStyle/>
+          <a:p>
+            <a:r>
+              <a:rPr lang="en-US" dirty="0"/>
+              <a:t>Data hazards – forwarding does not always work!</a:t>
+            </a:r>
+          </a:p>
+        </p:txBody>
+      </p:sp>
+      <p:pic>
+        <p:nvPicPr>
+          <p:cNvPr id="8" name="Content Placeholder 7">
+            <a:extLst>
+              <a:ext uri="{FF2B5EF4-FFF2-40B4-BE49-F238E27FC236}">
+                <a16:creationId xmlns:a16="http://schemas.microsoft.com/office/drawing/2014/main" id="{6097FE54-B195-15D9-61BF-8A82D5CFB7AE}"/>
+              </a:ext>
+            </a:extLst>
+          </p:cNvPr>
+          <p:cNvPicPr>
+            <a:picLocks noGrp="1" noChangeAspect="1"/>
+          </p:cNvPicPr>
+          <p:nvPr>
+            <p:ph idx="1"/>
+          </p:nvPr>
+        </p:nvPicPr>
+        <p:blipFill rotWithShape="1">
+          <a:blip r:embed="rId2"/>
+          <a:srcRect r="64740"/>
+          <a:stretch>
+            <a:fillRect/>
+          </a:stretch>
+        </p:blipFill>
+        <p:spPr>
+          <a:xfrm>
+            <a:off x="139262" y="1901058"/>
+            <a:ext cx="1649826" cy="1421560"/>
+          </a:xfrm>
+        </p:spPr>
+      </p:pic>
+      <p:sp>
+        <p:nvSpPr>
+          <p:cNvPr id="4" name="Date Placeholder 3">
+            <a:extLst>
+              <a:ext uri="{FF2B5EF4-FFF2-40B4-BE49-F238E27FC236}">
+                <a16:creationId xmlns:a16="http://schemas.microsoft.com/office/drawing/2014/main" id="{C2A35710-55ED-87E9-B542-BF3EFE81D815}"/>
+              </a:ext>
+            </a:extLst>
+          </p:cNvPr>
+          <p:cNvSpPr>
+            <a:spLocks noGrp="1"/>
+          </p:cNvSpPr>
+          <p:nvPr>
+            <p:ph type="dt" sz="half" idx="10"/>
+          </p:nvPr>
+        </p:nvSpPr>
+        <p:spPr/>
+        <p:txBody>
+          <a:bodyPr/>
+          <a:lstStyle/>
+          <a:p>
+            <a:fld id="{B4B13859-67C5-4393-B6C2-556CF3F770C0}" type="datetime3">
+              <a:rPr lang="en-US" smtClean="0"/>
+              <a:t>23 February 2026</a:t>
+            </a:fld>
+            <a:endParaRPr lang="en-US"/>
+          </a:p>
+        </p:txBody>
+      </p:sp>
+      <p:sp>
+        <p:nvSpPr>
+          <p:cNvPr id="5" name="Footer Placeholder 4">
+            <a:extLst>
+              <a:ext uri="{FF2B5EF4-FFF2-40B4-BE49-F238E27FC236}">
+                <a16:creationId xmlns:a16="http://schemas.microsoft.com/office/drawing/2014/main" id="{0E2855F0-8069-8AC7-6D5C-8613549B3B44}"/>
+              </a:ext>
+            </a:extLst>
+          </p:cNvPr>
+          <p:cNvSpPr>
+            <a:spLocks noGrp="1"/>
+          </p:cNvSpPr>
+          <p:nvPr>
+            <p:ph type="ftr" sz="quarter" idx="11"/>
+          </p:nvPr>
+        </p:nvSpPr>
+        <p:spPr/>
+        <p:txBody>
+          <a:bodyPr/>
+          <a:lstStyle/>
+          <a:p>
+            <a:r>
+              <a:rPr lang="en-US"/>
+              <a:t>ELL305: Computer Architecture</a:t>
+            </a:r>
+            <a:endParaRPr lang="en-US" dirty="0"/>
+          </a:p>
+        </p:txBody>
+      </p:sp>
+      <p:sp>
+        <p:nvSpPr>
+          <p:cNvPr id="6" name="Slide Number Placeholder 5">
+            <a:extLst>
+              <a:ext uri="{FF2B5EF4-FFF2-40B4-BE49-F238E27FC236}">
+                <a16:creationId xmlns:a16="http://schemas.microsoft.com/office/drawing/2014/main" id="{DB89A614-1F21-792D-092C-618E9A9299DB}"/>
+              </a:ext>
+            </a:extLst>
+          </p:cNvPr>
+          <p:cNvSpPr>
+            <a:spLocks noGrp="1"/>
+          </p:cNvSpPr>
+          <p:nvPr>
+            <p:ph type="sldNum" sz="quarter" idx="12"/>
+          </p:nvPr>
+        </p:nvSpPr>
+        <p:spPr/>
+        <p:txBody>
+          <a:bodyPr/>
+          <a:lstStyle/>
+          <a:p>
+            <a:fld id="{98AC3541-01C1-4CA5-B68F-FEE868C7D1AF}" type="slidenum">
+              <a:rPr lang="en-US" smtClean="0"/>
+              <a:t>20</a:t>
+            </a:fld>
+            <a:endParaRPr lang="en-US"/>
+          </a:p>
+        </p:txBody>
+      </p:sp>
+      <p:sp>
+        <p:nvSpPr>
+          <p:cNvPr id="9" name="Content Placeholder 2">
+            <a:extLst>
+              <a:ext uri="{FF2B5EF4-FFF2-40B4-BE49-F238E27FC236}">
+                <a16:creationId xmlns:a16="http://schemas.microsoft.com/office/drawing/2014/main" id="{6D997545-774F-B322-3189-57299FC4645F}"/>
+              </a:ext>
+            </a:extLst>
+          </p:cNvPr>
+          <p:cNvSpPr txBox="1">
+            <a:spLocks/>
+          </p:cNvSpPr>
+          <p:nvPr/>
+        </p:nvSpPr>
+        <p:spPr>
+          <a:xfrm>
+            <a:off x="4953000" y="1803546"/>
+            <a:ext cx="4035254" cy="1976101"/>
+          </a:xfrm>
+          <a:prstGeom prst="rect">
+            <a:avLst/>
+          </a:prstGeom>
+        </p:spPr>
+        <p:txBody>
+          <a:bodyPr vert="horz" lIns="68580" tIns="34290" rIns="68580" bIns="34290" rtlCol="0">
+            <a:noAutofit/>
+          </a:bodyPr>
+          <a:lstStyle>
+            <a:lvl1pPr marL="228600" indent="-228600" algn="l" defTabSz="914400" rtl="0" eaLnBrk="1" latinLnBrk="0" hangingPunct="1">
+              <a:lnSpc>
+                <a:spcPct val="90000"/>
+              </a:lnSpc>
+              <a:spcBef>
+                <a:spcPts val="1000"/>
+              </a:spcBef>
+              <a:buFont typeface="Arial" panose="020B0604020202020204" pitchFamily="34" charset="0"/>
+              <a:buChar char="•"/>
+              <a:defRPr sz="2400" kern="1200">
+                <a:solidFill>
+                  <a:schemeClr val="tx1"/>
+                </a:solidFill>
+                <a:latin typeface="+mn-lt"/>
+                <a:ea typeface="+mn-ea"/>
+                <a:cs typeface="+mn-cs"/>
+              </a:defRPr>
+            </a:lvl1pPr>
+            <a:lvl2pPr marL="685800" indent="-228600" algn="l" defTabSz="914400" rtl="0" eaLnBrk="1" latinLnBrk="0" hangingPunct="1">
+              <a:lnSpc>
+                <a:spcPct val="90000"/>
+              </a:lnSpc>
+              <a:spcBef>
+                <a:spcPts val="500"/>
+              </a:spcBef>
+              <a:buFont typeface="Arial" panose="020B0604020202020204" pitchFamily="34" charset="0"/>
+              <a:buChar char="•"/>
+              <a:defRPr sz="2000" kern="1200">
+                <a:solidFill>
+                  <a:schemeClr val="tx1"/>
+                </a:solidFill>
+                <a:latin typeface="+mn-lt"/>
+                <a:ea typeface="+mn-ea"/>
+                <a:cs typeface="+mn-cs"/>
+              </a:defRPr>
+            </a:lvl2pPr>
+            <a:lvl3pPr marL="1143000" indent="-228600" algn="l" defTabSz="914400" rtl="0" eaLnBrk="1" latinLnBrk="0" hangingPunct="1">
+              <a:lnSpc>
+                <a:spcPct val="90000"/>
+              </a:lnSpc>
+              <a:spcBef>
+                <a:spcPts val="500"/>
+              </a:spcBef>
+              <a:buFont typeface="Arial" panose="020B0604020202020204" pitchFamily="34" charset="0"/>
+              <a:buChar char="•"/>
+              <a:defRPr sz="1800" kern="1200">
+                <a:solidFill>
+                  <a:schemeClr val="tx1"/>
+                </a:solidFill>
+                <a:latin typeface="+mn-lt"/>
+                <a:ea typeface="+mn-ea"/>
+                <a:cs typeface="+mn-cs"/>
+              </a:defRPr>
+            </a:lvl3pPr>
+            <a:lvl4pPr marL="1600200" indent="-228600" algn="l" defTabSz="914400" rtl="0" eaLnBrk="1" latinLnBrk="0" hangingPunct="1">
+              <a:lnSpc>
+                <a:spcPct val="90000"/>
+              </a:lnSpc>
+              <a:spcBef>
+                <a:spcPts val="500"/>
+              </a:spcBef>
+              <a:buFont typeface="Arial" panose="020B0604020202020204" pitchFamily="34" charset="0"/>
+              <a:buChar char="•"/>
+              <a:defRPr sz="1600" kern="1200">
+                <a:solidFill>
+                  <a:schemeClr val="tx1"/>
+                </a:solidFill>
+                <a:latin typeface="+mn-lt"/>
+                <a:ea typeface="+mn-ea"/>
+                <a:cs typeface="+mn-cs"/>
+              </a:defRPr>
+            </a:lvl4pPr>
+            <a:lvl5pPr marL="2057400" indent="-228600" algn="l" defTabSz="914400" rtl="0" eaLnBrk="1" latinLnBrk="0" hangingPunct="1">
+              <a:lnSpc>
+                <a:spcPct val="90000"/>
+              </a:lnSpc>
+              <a:spcBef>
+                <a:spcPts val="500"/>
+              </a:spcBef>
+              <a:buFont typeface="Arial" panose="020B0604020202020204" pitchFamily="34" charset="0"/>
+              <a:buChar char="•"/>
+              <a:defRPr sz="1600" kern="1200">
+                <a:solidFill>
+                  <a:schemeClr val="tx1"/>
+                </a:solidFill>
+                <a:latin typeface="+mn-lt"/>
+                <a:ea typeface="+mn-ea"/>
+                <a:cs typeface="+mn-cs"/>
+              </a:defRPr>
+            </a:lvl5pPr>
+            <a:lvl6pPr marL="2514600" indent="-228600" algn="l" defTabSz="914400" rtl="0" eaLnBrk="1" latinLnBrk="0" hangingPunct="1">
+              <a:lnSpc>
+                <a:spcPct val="90000"/>
+              </a:lnSpc>
+              <a:spcBef>
+                <a:spcPts val="500"/>
+              </a:spcBef>
+              <a:buFont typeface="Arial" panose="020B0604020202020204" pitchFamily="34" charset="0"/>
+              <a:buChar char="•"/>
+              <a:defRPr sz="1800" kern="1200">
+                <a:solidFill>
+                  <a:schemeClr val="tx1"/>
+                </a:solidFill>
+                <a:latin typeface="+mn-lt"/>
+                <a:ea typeface="+mn-ea"/>
+                <a:cs typeface="+mn-cs"/>
+              </a:defRPr>
+            </a:lvl6pPr>
+            <a:lvl7pPr marL="2971800" indent="-228600" algn="l" defTabSz="914400" rtl="0" eaLnBrk="1" latinLnBrk="0" hangingPunct="1">
+              <a:lnSpc>
+                <a:spcPct val="90000"/>
+              </a:lnSpc>
+              <a:spcBef>
+                <a:spcPts val="500"/>
+              </a:spcBef>
+              <a:buFont typeface="Arial" panose="020B0604020202020204" pitchFamily="34" charset="0"/>
+              <a:buChar char="•"/>
+              <a:defRPr sz="1800" kern="1200">
+                <a:solidFill>
+                  <a:schemeClr val="tx1"/>
+                </a:solidFill>
+                <a:latin typeface="+mn-lt"/>
+                <a:ea typeface="+mn-ea"/>
+                <a:cs typeface="+mn-cs"/>
+              </a:defRPr>
+            </a:lvl7pPr>
+            <a:lvl8pPr marL="3429000" indent="-228600" algn="l" defTabSz="914400" rtl="0" eaLnBrk="1" latinLnBrk="0" hangingPunct="1">
+              <a:lnSpc>
+                <a:spcPct val="90000"/>
+              </a:lnSpc>
+              <a:spcBef>
+                <a:spcPts val="500"/>
+              </a:spcBef>
+              <a:buFont typeface="Arial" panose="020B0604020202020204" pitchFamily="34" charset="0"/>
+              <a:buChar char="•"/>
+              <a:defRPr sz="1800" kern="1200">
+                <a:solidFill>
+                  <a:schemeClr val="tx1"/>
+                </a:solidFill>
+                <a:latin typeface="+mn-lt"/>
+                <a:ea typeface="+mn-ea"/>
+                <a:cs typeface="+mn-cs"/>
+              </a:defRPr>
+            </a:lvl8pPr>
+            <a:lvl9pPr marL="3886200" indent="-228600" algn="l" defTabSz="914400" rtl="0" eaLnBrk="1" latinLnBrk="0" hangingPunct="1">
+              <a:lnSpc>
+                <a:spcPct val="90000"/>
+              </a:lnSpc>
+              <a:spcBef>
+                <a:spcPts val="500"/>
+              </a:spcBef>
+              <a:buFont typeface="Arial" panose="020B0604020202020204" pitchFamily="34" charset="0"/>
+              <a:buChar char="•"/>
+              <a:defRPr sz="1800" kern="1200">
+                <a:solidFill>
+                  <a:schemeClr val="tx1"/>
+                </a:solidFill>
+                <a:latin typeface="+mn-lt"/>
+                <a:ea typeface="+mn-ea"/>
+                <a:cs typeface="+mn-cs"/>
+              </a:defRPr>
+            </a:lvl9pPr>
+          </a:lstStyle>
+          <a:p>
+            <a:r>
+              <a:rPr lang="en-US" sz="2000" dirty="0"/>
+              <a:t>Hardware can stall the pipeline – hardware interlocks</a:t>
+            </a:r>
+          </a:p>
+          <a:p>
+            <a:r>
+              <a:rPr lang="en-US" sz="2000" dirty="0"/>
+              <a:t>Slot after ‘load’ is called a ‘load delay slot’</a:t>
+            </a:r>
+          </a:p>
+          <a:p>
+            <a:r>
+              <a:rPr lang="en-US" sz="2000" dirty="0"/>
+              <a:t>Re-ordering code, if possible, is always a good solution!</a:t>
+            </a:r>
+          </a:p>
+        </p:txBody>
+      </p:sp>
+      <p:pic>
+        <p:nvPicPr>
+          <p:cNvPr id="11" name="Picture 10">
+            <a:extLst>
+              <a:ext uri="{FF2B5EF4-FFF2-40B4-BE49-F238E27FC236}">
+                <a16:creationId xmlns:a16="http://schemas.microsoft.com/office/drawing/2014/main" id="{E12F6CF1-D9B4-364C-015B-C46492A9B6EA}"/>
+              </a:ext>
+            </a:extLst>
+          </p:cNvPr>
+          <p:cNvPicPr>
+            <a:picLocks noChangeAspect="1"/>
+          </p:cNvPicPr>
+          <p:nvPr/>
+        </p:nvPicPr>
+        <p:blipFill>
+          <a:blip r:embed="rId3"/>
+          <a:stretch>
+            <a:fillRect/>
+          </a:stretch>
+        </p:blipFill>
+        <p:spPr>
+          <a:xfrm>
+            <a:off x="1295400" y="3886200"/>
+            <a:ext cx="6630326" cy="2407780"/>
+          </a:xfrm>
+          <a:prstGeom prst="rect">
+            <a:avLst/>
+          </a:prstGeom>
+        </p:spPr>
+      </p:pic>
+      <p:sp>
+        <p:nvSpPr>
+          <p:cNvPr id="12" name="TextBox 11">
+            <a:extLst>
+              <a:ext uri="{FF2B5EF4-FFF2-40B4-BE49-F238E27FC236}">
+                <a16:creationId xmlns:a16="http://schemas.microsoft.com/office/drawing/2014/main" id="{6EAC05DF-0A8D-1E60-154B-DA359313514F}"/>
+              </a:ext>
+            </a:extLst>
+          </p:cNvPr>
+          <p:cNvSpPr txBox="1"/>
+          <p:nvPr/>
+        </p:nvSpPr>
+        <p:spPr>
+          <a:xfrm>
+            <a:off x="86736" y="1439035"/>
+            <a:ext cx="6999863" cy="369332"/>
+          </a:xfrm>
+          <a:prstGeom prst="rect">
+            <a:avLst/>
+          </a:prstGeom>
+          <a:noFill/>
+        </p:spPr>
+        <p:txBody>
+          <a:bodyPr wrap="square">
+            <a:spAutoFit/>
+          </a:bodyPr>
+          <a:lstStyle/>
+          <a:p>
+            <a:r>
+              <a:rPr lang="en-US" dirty="0">
+                <a:solidFill>
+                  <a:srgbClr val="FF0000"/>
+                </a:solidFill>
+              </a:rPr>
+              <a:t>Analyze this RAW hazard. What will you forward?</a:t>
+            </a:r>
+          </a:p>
+        </p:txBody>
+      </p:sp>
+    </p:spTree>
+    <p:extLst>
+      <p:ext uri="{BB962C8B-B14F-4D97-AF65-F5344CB8AC3E}">
+        <p14:creationId xmlns:p14="http://schemas.microsoft.com/office/powerpoint/2010/main" val="2671844509"/>
+      </p:ext>
+    </p:extLst>
+  </p:cSld>
+  <p:clrMapOvr>
+    <a:masterClrMapping/>
+  </p:clrMapOvr>
+  <p:timing>
+    <p:tnLst>
+      <p:par>
+        <p:cTn id="1" dur="indefinite" restart="never" nodeType="tmRoot">
+          <p:childTnLst>
+            <p:seq concurrent="1" nextAc="seek">
+              <p:cTn id="2" dur="indefinite" nodeType="mainSeq">
+                <p:childTnLst>
+                  <p:par>
+                    <p:cTn id="3" fill="hold">
+                      <p:stCondLst>
+                        <p:cond delay="indefinite"/>
+                      </p:stCondLst>
+                      <p:childTnLst>
+                        <p:par>
+                          <p:cTn id="4" fill="hold">
+                            <p:stCondLst>
+                              <p:cond delay="0"/>
+                            </p:stCondLst>
+                            <p:childTnLst>
+                              <p:par>
+                                <p:cTn id="5" presetID="1" presetClass="entr" presetSubtype="0" fill="hold" nodeType="clickEffect">
+                                  <p:stCondLst>
+                                    <p:cond delay="0"/>
+                                  </p:stCondLst>
+                                  <p:childTnLst>
+                                    <p:set>
+                                      <p:cBhvr>
+                                        <p:cTn id="6" dur="1" fill="hold">
+                                          <p:stCondLst>
+                                            <p:cond delay="0"/>
+                                          </p:stCondLst>
+                                        </p:cTn>
+                                        <p:tgtEl>
+                                          <p:spTgt spid="3"/>
+                                        </p:tgtEl>
+                                        <p:attrNameLst>
+                                          <p:attrName>style.visibility</p:attrName>
+                                        </p:attrNameLst>
+                                      </p:cBhvr>
+                                      <p:to>
+                                        <p:strVal val="visible"/>
+                                      </p:to>
+                                    </p:set>
+                                  </p:childTnLst>
+                                </p:cTn>
+                              </p:par>
+                            </p:childTnLst>
+                          </p:cTn>
+                        </p:par>
+                      </p:childTnLst>
+                    </p:cTn>
+                  </p:par>
+                  <p:par>
+                    <p:cTn id="7" fill="hold">
+                      <p:stCondLst>
+                        <p:cond delay="indefinite"/>
+                      </p:stCondLst>
+                      <p:childTnLst>
+                        <p:par>
+                          <p:cTn id="8" fill="hold">
+                            <p:stCondLst>
+                              <p:cond delay="0"/>
+                            </p:stCondLst>
+                            <p:childTnLst>
+                              <p:par>
+                                <p:cTn id="9" presetID="1" presetClass="entr" presetSubtype="0" fill="hold" grpId="0" nodeType="clickEffect">
+                                  <p:stCondLst>
+                                    <p:cond delay="0"/>
+                                  </p:stCondLst>
+                                  <p:childTnLst>
+                                    <p:set>
+                                      <p:cBhvr>
+                                        <p:cTn id="10" dur="1" fill="hold">
+                                          <p:stCondLst>
+                                            <p:cond delay="0"/>
+                                          </p:stCondLst>
+                                        </p:cTn>
+                                        <p:tgtEl>
+                                          <p:spTgt spid="2"/>
+                                        </p:tgtEl>
+                                        <p:attrNameLst>
+                                          <p:attrName>style.visibility</p:attrName>
+                                        </p:attrNameLst>
+                                      </p:cBhvr>
+                                      <p:to>
+                                        <p:strVal val="visible"/>
+                                      </p:to>
+                                    </p:set>
+                                  </p:childTnLst>
+                                </p:cTn>
+                              </p:par>
+                            </p:childTnLst>
+                          </p:cTn>
+                        </p:par>
+                      </p:childTnLst>
+                    </p:cTn>
+                  </p:par>
+                  <p:par>
+                    <p:cTn id="11" fill="hold">
+                      <p:stCondLst>
+                        <p:cond delay="indefinite"/>
+                      </p:stCondLst>
+                      <p:childTnLst>
+                        <p:par>
+                          <p:cTn id="12" fill="hold">
+                            <p:stCondLst>
+                              <p:cond delay="0"/>
+                            </p:stCondLst>
+                            <p:childTnLst>
+                              <p:par>
+                                <p:cTn id="13" presetID="1" presetClass="entr" presetSubtype="0" fill="hold" grpId="0" nodeType="clickEffect">
+                                  <p:stCondLst>
+                                    <p:cond delay="0"/>
+                                  </p:stCondLst>
+                                  <p:childTnLst>
+                                    <p:set>
+                                      <p:cBhvr>
+                                        <p:cTn id="14" dur="1" fill="hold">
+                                          <p:stCondLst>
+                                            <p:cond delay="0"/>
+                                          </p:stCondLst>
+                                        </p:cTn>
+                                        <p:tgtEl>
+                                          <p:spTgt spid="9">
+                                            <p:txEl>
+                                              <p:pRg st="0" end="0"/>
+                                            </p:txEl>
+                                          </p:spTgt>
+                                        </p:tgtEl>
+                                        <p:attrNameLst>
+                                          <p:attrName>style.visibility</p:attrName>
+                                        </p:attrNameLst>
+                                      </p:cBhvr>
+                                      <p:to>
+                                        <p:strVal val="visible"/>
+                                      </p:to>
+                                    </p:set>
+                                  </p:childTnLst>
+                                </p:cTn>
+                              </p:par>
+                            </p:childTnLst>
+                          </p:cTn>
+                        </p:par>
+                      </p:childTnLst>
+                    </p:cTn>
+                  </p:par>
+                  <p:par>
+                    <p:cTn id="15" fill="hold">
+                      <p:stCondLst>
+                        <p:cond delay="indefinite"/>
+                      </p:stCondLst>
+                      <p:childTnLst>
+                        <p:par>
+                          <p:cTn id="16" fill="hold">
+                            <p:stCondLst>
+                              <p:cond delay="0"/>
+                            </p:stCondLst>
+                            <p:childTnLst>
+                              <p:par>
+                                <p:cTn id="17" presetID="1" presetClass="entr" presetSubtype="0" fill="hold" grpId="0" nodeType="clickEffect">
+                                  <p:stCondLst>
+                                    <p:cond delay="0"/>
+                                  </p:stCondLst>
+                                  <p:childTnLst>
+                                    <p:set>
+                                      <p:cBhvr>
+                                        <p:cTn id="18" dur="1" fill="hold">
+                                          <p:stCondLst>
+                                            <p:cond delay="0"/>
+                                          </p:stCondLst>
+                                        </p:cTn>
+                                        <p:tgtEl>
+                                          <p:spTgt spid="9">
+                                            <p:txEl>
+                                              <p:pRg st="1" end="1"/>
+                                            </p:txEl>
+                                          </p:spTgt>
+                                        </p:tgtEl>
+                                        <p:attrNameLst>
+                                          <p:attrName>style.visibility</p:attrName>
+                                        </p:attrNameLst>
+                                      </p:cBhvr>
+                                      <p:to>
+                                        <p:strVal val="visible"/>
+                                      </p:to>
+                                    </p:set>
+                                  </p:childTnLst>
+                                </p:cTn>
+                              </p:par>
+                            </p:childTnLst>
+                          </p:cTn>
+                        </p:par>
+                      </p:childTnLst>
+                    </p:cTn>
+                  </p:par>
+                  <p:par>
+                    <p:cTn id="19" fill="hold">
+                      <p:stCondLst>
+                        <p:cond delay="indefinite"/>
+                      </p:stCondLst>
+                      <p:childTnLst>
+                        <p:par>
+                          <p:cTn id="20" fill="hold">
+                            <p:stCondLst>
+                              <p:cond delay="0"/>
+                            </p:stCondLst>
+                            <p:childTnLst>
+                              <p:par>
+                                <p:cTn id="21" presetID="1" presetClass="entr" presetSubtype="0" fill="hold" grpId="0" nodeType="clickEffect">
+                                  <p:stCondLst>
+                                    <p:cond delay="0"/>
+                                  </p:stCondLst>
+                                  <p:childTnLst>
+                                    <p:set>
+                                      <p:cBhvr>
+                                        <p:cTn id="22" dur="1" fill="hold">
+                                          <p:stCondLst>
+                                            <p:cond delay="0"/>
+                                          </p:stCondLst>
+                                        </p:cTn>
+                                        <p:tgtEl>
+                                          <p:spTgt spid="9">
+                                            <p:txEl>
+                                              <p:pRg st="2" end="2"/>
+                                            </p:txEl>
+                                          </p:spTgt>
+                                        </p:tgtEl>
+                                        <p:attrNameLst>
+                                          <p:attrName>style.visibility</p:attrName>
+                                        </p:attrNameLst>
+                                      </p:cBhvr>
+                                      <p:to>
+                                        <p:strVal val="visible"/>
+                                      </p:to>
+                                    </p:set>
+                                  </p:childTnLst>
+                                </p:cTn>
+                              </p:par>
+                            </p:childTnLst>
+                          </p:cTn>
+                        </p:par>
+                      </p:childTnLst>
+                    </p:cTn>
+                  </p:par>
+                  <p:par>
+                    <p:cTn id="23" fill="hold">
+                      <p:stCondLst>
+                        <p:cond delay="indefinite"/>
+                      </p:stCondLst>
+                      <p:childTnLst>
+                        <p:par>
+                          <p:cTn id="24" fill="hold">
+                            <p:stCondLst>
+                              <p:cond delay="0"/>
+                            </p:stCondLst>
+                            <p:childTnLst>
+                              <p:par>
+                                <p:cTn id="25" presetID="1" presetClass="entr" presetSubtype="0" fill="hold" nodeType="clickEffect">
+                                  <p:stCondLst>
+                                    <p:cond delay="0"/>
+                                  </p:stCondLst>
+                                  <p:childTnLst>
+                                    <p:set>
+                                      <p:cBhvr>
+                                        <p:cTn id="26" dur="1" fill="hold">
+                                          <p:stCondLst>
+                                            <p:cond delay="0"/>
+                                          </p:stCondLst>
+                                        </p:cTn>
+                                        <p:tgtEl>
+                                          <p:spTgt spid="11"/>
+                                        </p:tgtEl>
+                                        <p:attrNameLst>
+                                          <p:attrName>style.visibility</p:attrName>
+                                        </p:attrNameLst>
+                                      </p:cBhvr>
+                                      <p:to>
+                                        <p:strVal val="visible"/>
+                                      </p:to>
+                                    </p:set>
+                                  </p:childTnLst>
+                                </p:cTn>
+                              </p:par>
+                            </p:childTnLst>
+                          </p:cTn>
+                        </p:par>
+                      </p:childTnLst>
+                    </p:cTn>
+                  </p:par>
+                </p:childTnLst>
+              </p:cTn>
+              <p:prevCondLst>
+                <p:cond evt="onPrev" delay="0">
+                  <p:tgtEl>
+                    <p:sldTgt/>
+                  </p:tgtEl>
+                </p:cond>
+              </p:prevCondLst>
+              <p:nextCondLst>
+                <p:cond evt="onNext" delay="0">
+                  <p:tgtEl>
+                    <p:sldTgt/>
+                  </p:tgtEl>
+                </p:cond>
+              </p:nextCondLst>
+            </p:seq>
+          </p:childTnLst>
+        </p:cTn>
+      </p:par>
+    </p:tnLst>
+    <p:bldLst>
+      <p:bldP spid="2" grpId="0"/>
+      <p:bldP spid="9" grpId="0" build="p"/>
+    </p:bldLst>
+  </p:timing>
+</p:sld>
+</file>
+
 <file path=ppt/slides/slide3.xml><?xml version="1.0" encoding="utf-8"?>
 <p:sld xmlns:a="http://schemas.openxmlformats.org/drawingml/2006/main" xmlns:r="http://schemas.openxmlformats.org/officeDocument/2006/relationships" xmlns:p="http://schemas.openxmlformats.org/presentationml/2006/main">
   <p:cSld>
@@ -9103,7 +12652,7 @@
           <a:p>
             <a:fld id="{B4B13859-67C5-4393-B6C2-556CF3F770C0}" type="datetime3">
               <a:rPr lang="en-US" smtClean="0"/>
-              <a:t>20 February 2026</a:t>
+              <a:t>23 February 2026</a:t>
             </a:fld>
             <a:endParaRPr lang="en-US" dirty="0"/>
           </a:p>
@@ -9593,7 +13142,7 @@
           <a:p>
             <a:fld id="{B4B13859-67C5-4393-B6C2-556CF3F770C0}" type="datetime3">
               <a:rPr lang="en-US" smtClean="0"/>
-              <a:t>20 February 2026</a:t>
+              <a:t>23 February 2026</a:t>
             </a:fld>
             <a:endParaRPr lang="en-US" dirty="0"/>
           </a:p>
@@ -12017,7 +15566,7 @@
           <a:p>
             <a:fld id="{B4B13859-67C5-4393-B6C2-556CF3F770C0}" type="datetime3">
               <a:rPr lang="en-US" smtClean="0"/>
-              <a:t>20 February 2026</a:t>
+              <a:t>23 February 2026</a:t>
             </a:fld>
             <a:endParaRPr lang="en-US" dirty="0"/>
           </a:p>
@@ -12829,7 +16378,7 @@
           <a:p>
             <a:fld id="{B4B13859-67C5-4393-B6C2-556CF3F770C0}" type="datetime3">
               <a:rPr lang="en-US" smtClean="0"/>
-              <a:t>20 February 2026</a:t>
+              <a:t>23 February 2026</a:t>
             </a:fld>
             <a:endParaRPr lang="en-US" dirty="0"/>
           </a:p>
@@ -13069,7 +16618,7 @@
           <a:p>
             <a:fld id="{B4B13859-67C5-4393-B6C2-556CF3F770C0}" type="datetime3">
               <a:rPr lang="en-US" smtClean="0"/>
-              <a:t>20 February 2026</a:t>
+              <a:t>23 February 2026</a:t>
             </a:fld>
             <a:endParaRPr lang="en-US" dirty="0"/>
           </a:p>
@@ -13759,7 +17308,7 @@
           <a:p>
             <a:fld id="{B4B13859-67C5-4393-B6C2-556CF3F770C0}" type="datetime3">
               <a:rPr lang="en-US" smtClean="0"/>
-              <a:t>20 February 2026</a:t>
+              <a:t>23 February 2026</a:t>
             </a:fld>
             <a:endParaRPr lang="en-US" dirty="0"/>
           </a:p>
@@ -14345,7 +17894,7 @@
           <a:p>
             <a:fld id="{B4B13859-67C5-4393-B6C2-556CF3F770C0}" type="datetime3">
               <a:rPr lang="en-US" smtClean="0"/>
-              <a:t>20 February 2026</a:t>
+              <a:t>23 February 2026</a:t>
             </a:fld>
             <a:endParaRPr lang="en-US" dirty="0"/>
           </a:p>

</xml_diff>